<commit_message>
Fix text overlap in healing hotel deck when fonts are substituted
Co-Authored-By: Claude Opus 5.5 <noreply@anthropic.com>
Claude-Session: https://claude.ai/code/session_019koV41QHXrLyXuEfvuae5F
</commit_message>
<xml_diff>
--- a/康復療癒酒店整體設計規劃.pptx
+++ b/康復療癒酒店整體設計規劃.pptx
@@ -118,42 +118,42 @@
   <p:extLst>
     <p:ext uri="{521415D9-36F7-43E2-AB2F-B90AF26B5E84}">
       <p14:sectionLst xmlns:p14="http://schemas.microsoft.com/office/powerpoint/2010/main">
-        <p14:section name="開場" id="{0ba1133d-91eb-56f3-3d33-2a40bc0ced2c}">
+        <p14:section name="開場" id="{2bb96d02-aa96-068f-1d8c-b27736dc79f0}">
           <p14:sldIdLst>
             <p14:sldId id="256"/>
           </p14:sldIdLst>
         </p14:section>
-        <p14:section name="定位" id="{63f7e2eb-385f-2d54-6446-e2e9e8baf684}">
+        <p14:section name="定位" id="{5c098936-2424-72e9-2a33-a48402f77dfa}">
           <p14:sldIdLst>
             <p14:sldId id="257"/>
             <p14:sldId id="258"/>
             <p14:sldId id="259"/>
           </p14:sldIdLst>
         </p14:section>
-        <p14:section name="空間與服務" id="{d6c34bc1-a631-58f5-fb32-1ed5c7ad8537}">
+        <p14:section name="空間與服務" id="{2c98fff0-f1b1-0ca4-4a36-724e9e2d3863}">
           <p14:sldIdLst>
             <p14:sldId id="260"/>
             <p14:sldId id="261"/>
           </p14:sldIdLst>
         </p14:section>
-        <p14:section name="產品" id="{64917ddb-5a83-b56e-d2e7-2deb8fc63aa8}">
+        <p14:section name="產品" id="{2b8dc080-ab50-e477-851b-56488acdedf9}">
           <p14:sldIdLst>
             <p14:sldId id="262"/>
           </p14:sldIdLst>
         </p14:section>
-        <p14:section name="財務" id="{665bac64-5d34-c83d-ab11-cd6c904afcd7}">
+        <p14:section name="財務" id="{02104101-9fc1-efd8-4dd8-6552e3fa3653}">
           <p14:sldIdLst>
             <p14:sldId id="263"/>
             <p14:sldId id="264"/>
           </p14:sldIdLst>
         </p14:section>
-        <p14:section name="合規與執行" id="{8846c3eb-df37-224c-c5f1-730cef20aab0}">
+        <p14:section name="合規與執行" id="{f9f9d23e-9a0c-2eef-885c-d7602f2c3d0d}">
           <p14:sldIdLst>
             <p14:sldId id="265"/>
             <p14:sldId id="266"/>
           </p14:sldIdLst>
         </p14:section>
-        <p14:section name="下一步" id="{af6167ed-0942-e42c-4d1b-4fcf353fc353}">
+        <p14:section name="下一步" id="{603ff01d-9deb-1a33-66a5-4bd01f04ab76}">
           <p14:sldIdLst>
             <p14:sldId id="267"/>
           </p14:sldIdLst>
@@ -1985,6 +1985,9 @@
           <a:bodyPr wrap="square" rtlCol="0"/>
           <a:lstStyle>
             <a:lvl1pPr algn="l" indent="0" marL="0">
+              <a:lnSpc>
+                <a:spcPts val="4800"/>
+              </a:lnSpc>
               <a:buNone/>
               <a:defRPr lang="en-US" sz="4000" b="1" dirty="0">
                 <a:solidFill>
@@ -1995,6 +1998,9 @@
           </a:lstStyle>
           <a:p>
             <a:pPr algn="l" indent="0" marL="0">
+              <a:lnSpc>
+                <a:spcPts val="4800"/>
+              </a:lnSpc>
               <a:buNone/>
             </a:pPr>
             <a:endParaRPr lang="en-US" sz="4000" dirty="0"/>
@@ -2024,6 +2030,9 @@
           <a:bodyPr wrap="square" rtlCol="0"/>
           <a:lstStyle>
             <a:lvl1pPr indent="0" marL="0">
+              <a:lnSpc>
+                <a:spcPts val="2200"/>
+              </a:lnSpc>
               <a:buNone/>
               <a:defRPr lang="en-US" sz="1600" dirty="0">
                 <a:solidFill>
@@ -2034,6 +2043,9 @@
           </a:lstStyle>
           <a:p>
             <a:pPr indent="0" marL="0">
+              <a:lnSpc>
+                <a:spcPts val="2200"/>
+              </a:lnSpc>
               <a:buNone/>
             </a:pPr>
             <a:endParaRPr lang="en-US" sz="1600" dirty="0"/>
@@ -2095,6 +2107,9 @@
           <a:bodyPr wrap="square" rtlCol="0"/>
           <a:lstStyle>
             <a:lvl1pPr indent="0" marL="0">
+              <a:lnSpc>
+                <a:spcPts val="3400"/>
+              </a:lnSpc>
               <a:buNone/>
               <a:defRPr lang="en-US" sz="2800" b="1" dirty="0">
                 <a:solidFill>
@@ -2105,6 +2120,9 @@
           </a:lstStyle>
           <a:p>
             <a:pPr indent="0" marL="0">
+              <a:lnSpc>
+                <a:spcPts val="3400"/>
+              </a:lnSpc>
               <a:buNone/>
             </a:pPr>
             <a:endParaRPr lang="en-US" sz="2800" dirty="0"/>
@@ -2565,6 +2583,9 @@
           <a:lstStyle/>
           <a:p>
             <a:pPr algn="l" indent="0" marL="0">
+              <a:lnSpc>
+                <a:spcPts val="4800"/>
+              </a:lnSpc>
               <a:buNone/>
             </a:pPr>
             <a:r>
@@ -2603,6 +2624,9 @@
           <a:lstStyle/>
           <a:p>
             <a:pPr indent="0" marL="0">
+              <a:lnSpc>
+                <a:spcPts val="2200"/>
+              </a:lnSpc>
               <a:buNone/>
             </a:pPr>
             <a:r>
@@ -2617,6 +2641,9 @@
           </a:p>
           <a:p>
             <a:pPr indent="0" marL="0">
+              <a:lnSpc>
+                <a:spcPts val="2200"/>
+              </a:lnSpc>
               <a:buNone/>
             </a:pPr>
             <a:r>
@@ -2729,6 +2756,9 @@
           <a:lstStyle/>
           <a:p>
             <a:pPr indent="0" marL="0">
+              <a:lnSpc>
+                <a:spcPts val="3400"/>
+              </a:lnSpc>
               <a:buNone/>
             </a:pPr>
             <a:r>
@@ -2814,6 +2844,9 @@
           <a:lstStyle/>
           <a:p>
             <a:pPr indent="0" marL="0">
+              <a:lnSpc>
+                <a:spcPts val="2000"/>
+              </a:lnSpc>
               <a:buNone/>
             </a:pPr>
             <a:r>
@@ -2850,6 +2883,9 @@
           <a:lstStyle/>
           <a:p>
             <a:pPr indent="0" marL="0">
+              <a:lnSpc>
+                <a:spcPts val="1600"/>
+              </a:lnSpc>
               <a:buNone/>
             </a:pPr>
             <a:r>
@@ -2935,6 +2971,9 @@
           <a:lstStyle/>
           <a:p>
             <a:pPr indent="0" marL="0">
+              <a:lnSpc>
+                <a:spcPts val="2000"/>
+              </a:lnSpc>
               <a:buNone/>
             </a:pPr>
             <a:r>
@@ -2971,6 +3010,9 @@
           <a:lstStyle/>
           <a:p>
             <a:pPr indent="0" marL="0">
+              <a:lnSpc>
+                <a:spcPts val="1600"/>
+              </a:lnSpc>
               <a:buNone/>
             </a:pPr>
             <a:r>
@@ -3056,6 +3098,9 @@
           <a:lstStyle/>
           <a:p>
             <a:pPr indent="0" marL="0">
+              <a:lnSpc>
+                <a:spcPts val="2000"/>
+              </a:lnSpc>
               <a:buNone/>
             </a:pPr>
             <a:r>
@@ -3092,6 +3137,9 @@
           <a:lstStyle/>
           <a:p>
             <a:pPr indent="0" marL="0">
+              <a:lnSpc>
+                <a:spcPts val="1600"/>
+              </a:lnSpc>
               <a:buNone/>
             </a:pPr>
             <a:r>
@@ -3177,6 +3225,9 @@
           <a:lstStyle/>
           <a:p>
             <a:pPr indent="0" marL="0">
+              <a:lnSpc>
+                <a:spcPts val="2000"/>
+              </a:lnSpc>
               <a:buNone/>
             </a:pPr>
             <a:r>
@@ -3213,6 +3264,9 @@
           <a:lstStyle/>
           <a:p>
             <a:pPr indent="0" marL="0">
+              <a:lnSpc>
+                <a:spcPts val="1600"/>
+              </a:lnSpc>
               <a:buNone/>
             </a:pPr>
             <a:r>
@@ -3298,6 +3352,9 @@
           <a:lstStyle/>
           <a:p>
             <a:pPr indent="0" marL="0">
+              <a:lnSpc>
+                <a:spcPts val="2000"/>
+              </a:lnSpc>
               <a:buNone/>
             </a:pPr>
             <a:r>
@@ -3334,6 +3391,9 @@
           <a:lstStyle/>
           <a:p>
             <a:pPr indent="0" marL="0">
+              <a:lnSpc>
+                <a:spcPts val="1600"/>
+              </a:lnSpc>
               <a:buNone/>
             </a:pPr>
             <a:r>
@@ -3397,6 +3457,9 @@
           <a:lstStyle/>
           <a:p>
             <a:pPr indent="0" marL="0">
+              <a:lnSpc>
+                <a:spcPts val="1800"/>
+              </a:lnSpc>
               <a:buNone/>
             </a:pPr>
             <a:r>
@@ -3505,6 +3568,9 @@
           <a:lstStyle/>
           <a:p>
             <a:pPr indent="0" marL="0">
+              <a:lnSpc>
+                <a:spcPts val="3400"/>
+              </a:lnSpc>
               <a:buNone/>
             </a:pPr>
             <a:r>
@@ -3589,6 +3655,9 @@
           <a:lstStyle/>
           <a:p>
             <a:pPr algn="ctr" indent="0" marL="0">
+              <a:lnSpc>
+                <a:spcPts val="2300"/>
+              </a:lnSpc>
               <a:buNone/>
             </a:pPr>
             <a:r>
@@ -3625,6 +3694,9 @@
           <a:lstStyle/>
           <a:p>
             <a:pPr algn="ctr" indent="0" marL="0">
+              <a:lnSpc>
+                <a:spcPts val="1900"/>
+              </a:lnSpc>
               <a:buNone/>
             </a:pPr>
             <a:r>
@@ -3661,6 +3733,9 @@
           <a:lstStyle/>
           <a:p>
             <a:pPr indent="0" marL="0">
+              <a:lnSpc>
+                <a:spcPts val="1500"/>
+              </a:lnSpc>
               <a:buNone/>
             </a:pPr>
             <a:r>
@@ -3722,6 +3797,9 @@
           <a:lstStyle/>
           <a:p>
             <a:pPr algn="ctr" indent="0" marL="0">
+              <a:lnSpc>
+                <a:spcPts val="2300"/>
+              </a:lnSpc>
               <a:buNone/>
             </a:pPr>
             <a:r>
@@ -3758,6 +3836,9 @@
           <a:lstStyle/>
           <a:p>
             <a:pPr algn="ctr" indent="0" marL="0">
+              <a:lnSpc>
+                <a:spcPts val="1900"/>
+              </a:lnSpc>
               <a:buNone/>
             </a:pPr>
             <a:r>
@@ -3794,6 +3875,9 @@
           <a:lstStyle/>
           <a:p>
             <a:pPr indent="0" marL="0">
+              <a:lnSpc>
+                <a:spcPts val="1500"/>
+              </a:lnSpc>
               <a:buNone/>
             </a:pPr>
             <a:r>
@@ -3855,6 +3939,9 @@
           <a:lstStyle/>
           <a:p>
             <a:pPr algn="ctr" indent="0" marL="0">
+              <a:lnSpc>
+                <a:spcPts val="2300"/>
+              </a:lnSpc>
               <a:buNone/>
             </a:pPr>
             <a:r>
@@ -3891,6 +3978,9 @@
           <a:lstStyle/>
           <a:p>
             <a:pPr algn="ctr" indent="0" marL="0">
+              <a:lnSpc>
+                <a:spcPts val="1900"/>
+              </a:lnSpc>
               <a:buNone/>
             </a:pPr>
             <a:r>
@@ -3927,6 +4017,9 @@
           <a:lstStyle/>
           <a:p>
             <a:pPr indent="0" marL="0">
+              <a:lnSpc>
+                <a:spcPts val="1500"/>
+              </a:lnSpc>
               <a:buNone/>
             </a:pPr>
             <a:r>
@@ -3988,6 +4081,9 @@
           <a:lstStyle/>
           <a:p>
             <a:pPr algn="ctr" indent="0" marL="0">
+              <a:lnSpc>
+                <a:spcPts val="2300"/>
+              </a:lnSpc>
               <a:buNone/>
             </a:pPr>
             <a:r>
@@ -4024,6 +4120,9 @@
           <a:lstStyle/>
           <a:p>
             <a:pPr algn="ctr" indent="0" marL="0">
+              <a:lnSpc>
+                <a:spcPts val="1900"/>
+              </a:lnSpc>
               <a:buNone/>
             </a:pPr>
             <a:r>
@@ -4060,6 +4159,9 @@
           <a:lstStyle/>
           <a:p>
             <a:pPr indent="0" marL="0">
+              <a:lnSpc>
+                <a:spcPts val="1500"/>
+              </a:lnSpc>
               <a:buNone/>
             </a:pPr>
             <a:r>
@@ -4121,6 +4223,9 @@
           <a:lstStyle/>
           <a:p>
             <a:pPr algn="ctr" indent="0" marL="0">
+              <a:lnSpc>
+                <a:spcPts val="2300"/>
+              </a:lnSpc>
               <a:buNone/>
             </a:pPr>
             <a:r>
@@ -4157,6 +4262,9 @@
           <a:lstStyle/>
           <a:p>
             <a:pPr algn="ctr" indent="0" marL="0">
+              <a:lnSpc>
+                <a:spcPts val="1900"/>
+              </a:lnSpc>
               <a:buNone/>
             </a:pPr>
             <a:r>
@@ -4193,6 +4301,9 @@
           <a:lstStyle/>
           <a:p>
             <a:pPr indent="0" marL="0">
+              <a:lnSpc>
+                <a:spcPts val="1500"/>
+              </a:lnSpc>
               <a:buNone/>
             </a:pPr>
             <a:r>
@@ -4229,6 +4340,9 @@
           <a:lstStyle/>
           <a:p>
             <a:pPr indent="0" marL="0">
+              <a:lnSpc>
+                <a:spcPts val="1600"/>
+              </a:lnSpc>
               <a:buNone/>
             </a:pPr>
             <a:r>
@@ -4337,6 +4451,9 @@
           <a:lstStyle/>
           <a:p>
             <a:pPr algn="l" indent="0" marL="0">
+              <a:lnSpc>
+                <a:spcPts val="4800"/>
+              </a:lnSpc>
               <a:buNone/>
             </a:pPr>
             <a:r>
@@ -4375,6 +4492,9 @@
           <a:lstStyle/>
           <a:p>
             <a:pPr indent="0" marL="0">
+              <a:lnSpc>
+                <a:spcPts val="2200"/>
+              </a:lnSpc>
               <a:buNone/>
             </a:pPr>
             <a:r>
@@ -4438,6 +4558,9 @@
           <a:lstStyle/>
           <a:p>
             <a:pPr indent="0" marL="0">
+              <a:lnSpc>
+                <a:spcPts val="1500"/>
+              </a:lnSpc>
               <a:buNone/>
             </a:pPr>
             <a:r>
@@ -4501,6 +4624,9 @@
           <a:lstStyle/>
           <a:p>
             <a:pPr indent="0" marL="0">
+              <a:lnSpc>
+                <a:spcPts val="1500"/>
+              </a:lnSpc>
               <a:buNone/>
             </a:pPr>
             <a:r>
@@ -4564,6 +4690,9 @@
           <a:lstStyle/>
           <a:p>
             <a:pPr indent="0" marL="0">
+              <a:lnSpc>
+                <a:spcPts val="1500"/>
+              </a:lnSpc>
               <a:buNone/>
             </a:pPr>
             <a:r>
@@ -4627,6 +4756,9 @@
           <a:lstStyle/>
           <a:p>
             <a:pPr indent="0" marL="0">
+              <a:lnSpc>
+                <a:spcPts val="1500"/>
+              </a:lnSpc>
               <a:buNone/>
             </a:pPr>
             <a:r>
@@ -4635,7 +4767,7 @@
                   <a:schemeClr val="bg1"/>
                 </a:solidFill>
               </a:rPr>
-              <a:t>4 投資預算（人民幣）</a:t>
+              <a:t>4 投資預算</a:t>
             </a:r>
             <a:endParaRPr lang="en-US" sz="1200" dirty="0"/>
           </a:p>
@@ -4690,6 +4822,9 @@
           <a:lstStyle/>
           <a:p>
             <a:pPr indent="0" marL="0">
+              <a:lnSpc>
+                <a:spcPts val="3400"/>
+              </a:lnSpc>
               <a:buNone/>
             </a:pPr>
             <a:r>
@@ -4753,6 +4888,9 @@
           <a:lstStyle/>
           <a:p>
             <a:pPr indent="0" marL="0">
+              <a:lnSpc>
+                <a:spcPts val="2800"/>
+              </a:lnSpc>
               <a:buNone/>
             </a:pPr>
             <a:r>
@@ -4789,6 +4927,9 @@
           <a:lstStyle/>
           <a:p>
             <a:pPr indent="0" marL="0">
+              <a:lnSpc>
+                <a:spcPts val="1900"/>
+              </a:lnSpc>
               <a:buNone/>
             </a:pPr>
             <a:r>
@@ -4825,6 +4966,9 @@
           <a:lstStyle/>
           <a:p>
             <a:pPr indent="0" marL="0">
+              <a:lnSpc>
+                <a:spcPts val="2000"/>
+              </a:lnSpc>
               <a:buNone/>
             </a:pPr>
             <a:r>
@@ -4886,6 +5030,9 @@
           <a:lstStyle/>
           <a:p>
             <a:pPr algn="ctr" indent="0" marL="0">
+              <a:lnSpc>
+                <a:spcPts val="2300"/>
+              </a:lnSpc>
               <a:buNone/>
             </a:pPr>
             <a:r>
@@ -4922,6 +5069,9 @@
           <a:lstStyle/>
           <a:p>
             <a:pPr indent="0" marL="0">
+              <a:lnSpc>
+                <a:spcPts val="2000"/>
+              </a:lnSpc>
               <a:buNone/>
             </a:pPr>
             <a:r>
@@ -4958,6 +5108,9 @@
           <a:lstStyle/>
           <a:p>
             <a:pPr indent="0" marL="0">
+              <a:lnSpc>
+                <a:spcPts val="1600"/>
+              </a:lnSpc>
               <a:buNone/>
             </a:pPr>
             <a:r>
@@ -5019,6 +5172,9 @@
           <a:lstStyle/>
           <a:p>
             <a:pPr algn="ctr" indent="0" marL="0">
+              <a:lnSpc>
+                <a:spcPts val="2300"/>
+              </a:lnSpc>
               <a:buNone/>
             </a:pPr>
             <a:r>
@@ -5055,6 +5211,9 @@
           <a:lstStyle/>
           <a:p>
             <a:pPr indent="0" marL="0">
+              <a:lnSpc>
+                <a:spcPts val="2000"/>
+              </a:lnSpc>
               <a:buNone/>
             </a:pPr>
             <a:r>
@@ -5091,6 +5250,9 @@
           <a:lstStyle/>
           <a:p>
             <a:pPr indent="0" marL="0">
+              <a:lnSpc>
+                <a:spcPts val="1600"/>
+              </a:lnSpc>
               <a:buNone/>
             </a:pPr>
             <a:r>
@@ -5152,6 +5314,9 @@
           <a:lstStyle/>
           <a:p>
             <a:pPr algn="ctr" indent="0" marL="0">
+              <a:lnSpc>
+                <a:spcPts val="2300"/>
+              </a:lnSpc>
               <a:buNone/>
             </a:pPr>
             <a:r>
@@ -5188,6 +5353,9 @@
           <a:lstStyle/>
           <a:p>
             <a:pPr indent="0" marL="0">
+              <a:lnSpc>
+                <a:spcPts val="2000"/>
+              </a:lnSpc>
               <a:buNone/>
             </a:pPr>
             <a:r>
@@ -5224,6 +5392,9 @@
           <a:lstStyle/>
           <a:p>
             <a:pPr indent="0" marL="0">
+              <a:lnSpc>
+                <a:spcPts val="1600"/>
+              </a:lnSpc>
               <a:buNone/>
             </a:pPr>
             <a:r>
@@ -5332,6 +5503,9 @@
           <a:lstStyle/>
           <a:p>
             <a:pPr indent="0" marL="0">
+              <a:lnSpc>
+                <a:spcPts val="3400"/>
+              </a:lnSpc>
               <a:buNone/>
             </a:pPr>
             <a:r>
@@ -5368,6 +5542,9 @@
           <a:lstStyle/>
           <a:p>
             <a:pPr indent="0" marL="0">
+              <a:lnSpc>
+                <a:spcPts val="1600"/>
+              </a:lnSpc>
               <a:buNone/>
             </a:pPr>
             <a:r>
@@ -5376,7 +5553,7 @@
                   <a:schemeClr val="accent5"/>
                 </a:solidFill>
               </a:rPr>
-              <a:t>以睡眠品質、壓力舒緩、自然環境、節氣飲食及溫和身體活動為核心（暫定方向，可依地點與規模調整）</a:t>
+              <a:t>以睡眠、減壓、自然環境、節氣飲食與溫和活動為核心（暫定方向）</a:t>
             </a:r>
             <a:endParaRPr lang="en-US" sz="1300" dirty="0"/>
           </a:p>
@@ -5480,6 +5657,9 @@
           <a:lstStyle/>
           <a:p>
             <a:pPr indent="0" marL="0">
+              <a:lnSpc>
+                <a:spcPts val="2100"/>
+              </a:lnSpc>
               <a:buNone/>
             </a:pPr>
             <a:r>
@@ -5516,6 +5696,9 @@
           <a:lstStyle/>
           <a:p>
             <a:pPr indent="0" marL="0">
+              <a:lnSpc>
+                <a:spcPts val="1600"/>
+              </a:lnSpc>
               <a:buNone/>
             </a:pPr>
             <a:r>
@@ -5628,6 +5811,9 @@
           <a:lstStyle/>
           <a:p>
             <a:pPr indent="0" marL="0">
+              <a:lnSpc>
+                <a:spcPts val="2100"/>
+              </a:lnSpc>
               <a:buNone/>
             </a:pPr>
             <a:r>
@@ -5664,6 +5850,9 @@
           <a:lstStyle/>
           <a:p>
             <a:pPr indent="0" marL="0">
+              <a:lnSpc>
+                <a:spcPts val="1600"/>
+              </a:lnSpc>
               <a:buNone/>
             </a:pPr>
             <a:r>
@@ -5776,6 +5965,9 @@
           <a:lstStyle/>
           <a:p>
             <a:pPr indent="0" marL="0">
+              <a:lnSpc>
+                <a:spcPts val="2100"/>
+              </a:lnSpc>
               <a:buNone/>
             </a:pPr>
             <a:r>
@@ -5812,6 +6004,9 @@
           <a:lstStyle/>
           <a:p>
             <a:pPr indent="0" marL="0">
+              <a:lnSpc>
+                <a:spcPts val="1600"/>
+              </a:lnSpc>
               <a:buNone/>
             </a:pPr>
             <a:r>
@@ -5924,6 +6119,9 @@
           <a:lstStyle/>
           <a:p>
             <a:pPr indent="0" marL="0">
+              <a:lnSpc>
+                <a:spcPts val="2100"/>
+              </a:lnSpc>
               <a:buNone/>
             </a:pPr>
             <a:r>
@@ -5960,6 +6158,9 @@
           <a:lstStyle/>
           <a:p>
             <a:pPr indent="0" marL="0">
+              <a:lnSpc>
+                <a:spcPts val="1600"/>
+              </a:lnSpc>
               <a:buNone/>
             </a:pPr>
             <a:r>
@@ -6068,6 +6269,9 @@
           <a:lstStyle/>
           <a:p>
             <a:pPr indent="0" marL="0">
+              <a:lnSpc>
+                <a:spcPts val="3400"/>
+              </a:lnSpc>
               <a:buNone/>
             </a:pPr>
             <a:r>
@@ -6180,6 +6384,9 @@
           <a:lstStyle/>
           <a:p>
             <a:pPr indent="0" marL="0">
+              <a:lnSpc>
+                <a:spcPts val="2100"/>
+              </a:lnSpc>
               <a:buNone/>
             </a:pPr>
             <a:r>
@@ -6216,6 +6423,9 @@
           <a:lstStyle/>
           <a:p>
             <a:pPr marL="342900" indent="-342900">
+              <a:lnSpc>
+                <a:spcPts val="1800"/>
+              </a:lnSpc>
               <a:spcAft>
                 <a:spcPts val="600"/>
               </a:spcAft>
@@ -6234,6 +6444,9 @@
           </a:p>
           <a:p>
             <a:pPr marL="342900" indent="-342900">
+              <a:lnSpc>
+                <a:spcPts val="1800"/>
+              </a:lnSpc>
               <a:spcAft>
                 <a:spcPts val="600"/>
               </a:spcAft>
@@ -6252,6 +6465,9 @@
           </a:p>
           <a:p>
             <a:pPr marL="342900" indent="-342900">
+              <a:lnSpc>
+                <a:spcPts val="1800"/>
+              </a:lnSpc>
               <a:spcAft>
                 <a:spcPts val="600"/>
               </a:spcAft>
@@ -6270,6 +6486,9 @@
           </a:p>
           <a:p>
             <a:pPr marL="342900" indent="-342900">
+              <a:lnSpc>
+                <a:spcPts val="1800"/>
+              </a:lnSpc>
               <a:spcAft>
                 <a:spcPts val="600"/>
               </a:spcAft>
@@ -6386,6 +6605,9 @@
           <a:lstStyle/>
           <a:p>
             <a:pPr indent="0" marL="0">
+              <a:lnSpc>
+                <a:spcPts val="2100"/>
+              </a:lnSpc>
               <a:buNone/>
             </a:pPr>
             <a:r>
@@ -6422,6 +6644,9 @@
           <a:lstStyle/>
           <a:p>
             <a:pPr marL="342900" indent="-342900">
+              <a:lnSpc>
+                <a:spcPts val="1800"/>
+              </a:lnSpc>
               <a:spcAft>
                 <a:spcPts val="600"/>
               </a:spcAft>
@@ -6440,6 +6665,9 @@
           </a:p>
           <a:p>
             <a:pPr marL="342900" indent="-342900">
+              <a:lnSpc>
+                <a:spcPts val="1800"/>
+              </a:lnSpc>
               <a:spcAft>
                 <a:spcPts val="600"/>
               </a:spcAft>
@@ -6458,6 +6686,9 @@
           </a:p>
           <a:p>
             <a:pPr marL="342900" indent="-342900">
+              <a:lnSpc>
+                <a:spcPts val="1800"/>
+              </a:lnSpc>
               <a:spcAft>
                 <a:spcPts val="600"/>
               </a:spcAft>
@@ -6476,6 +6707,9 @@
           </a:p>
           <a:p>
             <a:pPr marL="342900" indent="-342900">
+              <a:lnSpc>
+                <a:spcPts val="1800"/>
+              </a:lnSpc>
               <a:spcAft>
                 <a:spcPts val="600"/>
               </a:spcAft>
@@ -6516,6 +6750,9 @@
           <a:lstStyle/>
           <a:p>
             <a:pPr indent="0" marL="0">
+              <a:lnSpc>
+                <a:spcPts val="1600"/>
+              </a:lnSpc>
               <a:buNone/>
             </a:pPr>
             <a:r>
@@ -6624,6 +6861,9 @@
           <a:lstStyle/>
           <a:p>
             <a:pPr indent="0" marL="0">
+              <a:lnSpc>
+                <a:spcPts val="3400"/>
+              </a:lnSpc>
               <a:buNone/>
             </a:pPr>
             <a:r>
@@ -6687,6 +6927,9 @@
           <a:lstStyle/>
           <a:p>
             <a:pPr algn="ctr" indent="0" marL="0">
+              <a:lnSpc>
+                <a:spcPts val="9000"/>
+              </a:lnSpc>
               <a:buNone/>
             </a:pPr>
             <a:r>
@@ -6723,6 +6966,9 @@
           <a:lstStyle/>
           <a:p>
             <a:pPr algn="ctr" indent="0" marL="0">
+              <a:lnSpc>
+                <a:spcPts val="2000"/>
+              </a:lnSpc>
               <a:buNone/>
             </a:pPr>
             <a:r>
@@ -6759,6 +7005,9 @@
           <a:lstStyle/>
           <a:p>
             <a:pPr indent="0" marL="0">
+              <a:lnSpc>
+                <a:spcPts val="1500"/>
+              </a:lnSpc>
               <a:buNone/>
             </a:pPr>
             <a:r>
@@ -6844,6 +7093,9 @@
           <a:lstStyle/>
           <a:p>
             <a:pPr indent="0" marL="0">
+              <a:lnSpc>
+                <a:spcPts val="2000"/>
+              </a:lnSpc>
               <a:buNone/>
             </a:pPr>
             <a:r>
@@ -6880,6 +7132,9 @@
           <a:lstStyle/>
           <a:p>
             <a:pPr indent="0" marL="0">
+              <a:lnSpc>
+                <a:spcPts val="1600"/>
+              </a:lnSpc>
               <a:buNone/>
             </a:pPr>
             <a:r>
@@ -6965,6 +7220,9 @@
           <a:lstStyle/>
           <a:p>
             <a:pPr indent="0" marL="0">
+              <a:lnSpc>
+                <a:spcPts val="2000"/>
+              </a:lnSpc>
               <a:buNone/>
             </a:pPr>
             <a:r>
@@ -7001,6 +7259,9 @@
           <a:lstStyle/>
           <a:p>
             <a:pPr indent="0" marL="0">
+              <a:lnSpc>
+                <a:spcPts val="1600"/>
+              </a:lnSpc>
               <a:buNone/>
             </a:pPr>
             <a:r>
@@ -7086,6 +7347,9 @@
           <a:lstStyle/>
           <a:p>
             <a:pPr indent="0" marL="0">
+              <a:lnSpc>
+                <a:spcPts val="2000"/>
+              </a:lnSpc>
               <a:buNone/>
             </a:pPr>
             <a:r>
@@ -7122,6 +7386,9 @@
           <a:lstStyle/>
           <a:p>
             <a:pPr indent="0" marL="0">
+              <a:lnSpc>
+                <a:spcPts val="1600"/>
+              </a:lnSpc>
               <a:buNone/>
             </a:pPr>
             <a:r>
@@ -7230,6 +7497,9 @@
           <a:lstStyle/>
           <a:p>
             <a:pPr indent="0" marL="0">
+              <a:lnSpc>
+                <a:spcPts val="3400"/>
+              </a:lnSpc>
               <a:buNone/>
             </a:pPr>
             <a:r>
@@ -7293,6 +7563,9 @@
           <a:lstStyle/>
           <a:p>
             <a:pPr indent="0" marL="0">
+              <a:lnSpc>
+                <a:spcPts val="4500"/>
+              </a:lnSpc>
               <a:buNone/>
             </a:pPr>
             <a:r>
@@ -7329,6 +7602,9 @@
           <a:lstStyle/>
           <a:p>
             <a:pPr indent="0" marL="0">
+              <a:lnSpc>
+                <a:spcPts val="1900"/>
+              </a:lnSpc>
               <a:buNone/>
             </a:pPr>
             <a:r>
@@ -7365,6 +7641,9 @@
           <a:lstStyle/>
           <a:p>
             <a:pPr indent="0" marL="0">
+              <a:lnSpc>
+                <a:spcPts val="1500"/>
+              </a:lnSpc>
               <a:buNone/>
             </a:pPr>
             <a:r>
@@ -7428,6 +7707,9 @@
           <a:lstStyle/>
           <a:p>
             <a:pPr indent="0" marL="0">
+              <a:lnSpc>
+                <a:spcPts val="4500"/>
+              </a:lnSpc>
               <a:buNone/>
             </a:pPr>
             <a:r>
@@ -7464,6 +7746,9 @@
           <a:lstStyle/>
           <a:p>
             <a:pPr indent="0" marL="0">
+              <a:lnSpc>
+                <a:spcPts val="1900"/>
+              </a:lnSpc>
               <a:buNone/>
             </a:pPr>
             <a:r>
@@ -7500,6 +7785,9 @@
           <a:lstStyle/>
           <a:p>
             <a:pPr indent="0" marL="0">
+              <a:lnSpc>
+                <a:spcPts val="1500"/>
+              </a:lnSpc>
               <a:buNone/>
             </a:pPr>
             <a:r>
@@ -7563,6 +7851,9 @@
           <a:lstStyle/>
           <a:p>
             <a:pPr indent="0" marL="0">
+              <a:lnSpc>
+                <a:spcPts val="4500"/>
+              </a:lnSpc>
               <a:buNone/>
             </a:pPr>
             <a:r>
@@ -7599,6 +7890,9 @@
           <a:lstStyle/>
           <a:p>
             <a:pPr indent="0" marL="0">
+              <a:lnSpc>
+                <a:spcPts val="1900"/>
+              </a:lnSpc>
               <a:buNone/>
             </a:pPr>
             <a:r>
@@ -7635,6 +7929,9 @@
           <a:lstStyle/>
           <a:p>
             <a:pPr indent="0" marL="0">
+              <a:lnSpc>
+                <a:spcPts val="1500"/>
+              </a:lnSpc>
               <a:buNone/>
             </a:pPr>
             <a:r>
@@ -7698,6 +7995,9 @@
           <a:lstStyle/>
           <a:p>
             <a:pPr indent="0" marL="0">
+              <a:lnSpc>
+                <a:spcPts val="4500"/>
+              </a:lnSpc>
               <a:buNone/>
             </a:pPr>
             <a:r>
@@ -7734,6 +8034,9 @@
           <a:lstStyle/>
           <a:p>
             <a:pPr indent="0" marL="0">
+              <a:lnSpc>
+                <a:spcPts val="1900"/>
+              </a:lnSpc>
               <a:buNone/>
             </a:pPr>
             <a:r>
@@ -7770,6 +8073,9 @@
           <a:lstStyle/>
           <a:p>
             <a:pPr indent="0" marL="0">
+              <a:lnSpc>
+                <a:spcPts val="1500"/>
+              </a:lnSpc>
               <a:buNone/>
             </a:pPr>
             <a:r>
@@ -7806,6 +8112,9 @@
           <a:lstStyle/>
           <a:p>
             <a:pPr indent="0" marL="0">
+              <a:lnSpc>
+                <a:spcPts val="1500"/>
+              </a:lnSpc>
               <a:buNone/>
             </a:pPr>
             <a:r>
@@ -7914,6 +8223,9 @@
           <a:lstStyle/>
           <a:p>
             <a:pPr indent="0" marL="0">
+              <a:lnSpc>
+                <a:spcPts val="3400"/>
+              </a:lnSpc>
               <a:buNone/>
             </a:pPr>
             <a:r>
@@ -7950,6 +8262,9 @@
           <a:lstStyle/>
           <a:p>
             <a:pPr indent="0" marL="0">
+              <a:lnSpc>
+                <a:spcPts val="1600"/>
+              </a:lnSpc>
               <a:buNone/>
             </a:pPr>
             <a:r>
@@ -8013,6 +8328,9 @@
           <a:lstStyle/>
           <a:p>
             <a:pPr indent="0" marL="0">
+              <a:lnSpc>
+                <a:spcPts val="1500"/>
+              </a:lnSpc>
               <a:buNone/>
             </a:pPr>
             <a:r>
@@ -8049,6 +8367,9 @@
           <a:lstStyle/>
           <a:p>
             <a:pPr indent="0" marL="0">
+              <a:lnSpc>
+                <a:spcPts val="2300"/>
+              </a:lnSpc>
               <a:buNone/>
             </a:pPr>
             <a:r>
@@ -8085,6 +8406,9 @@
           <a:lstStyle/>
           <a:p>
             <a:pPr marL="342900" indent="-342900">
+              <a:lnSpc>
+                <a:spcPts val="1600"/>
+              </a:lnSpc>
               <a:spcAft>
                 <a:spcPts val="300"/>
               </a:spcAft>
@@ -8103,6 +8427,9 @@
           </a:p>
           <a:p>
             <a:pPr marL="342900" indent="-342900">
+              <a:lnSpc>
+                <a:spcPts val="1600"/>
+              </a:lnSpc>
               <a:spcAft>
                 <a:spcPts val="300"/>
               </a:spcAft>
@@ -8121,6 +8448,9 @@
           </a:p>
           <a:p>
             <a:pPr marL="342900" indent="-342900">
+              <a:lnSpc>
+                <a:spcPts val="1600"/>
+              </a:lnSpc>
               <a:spcAft>
                 <a:spcPts val="300"/>
               </a:spcAft>
@@ -8139,6 +8469,9 @@
           </a:p>
           <a:p>
             <a:pPr marL="342900" indent="-342900">
+              <a:lnSpc>
+                <a:spcPts val="1600"/>
+              </a:lnSpc>
               <a:spcAft>
                 <a:spcPts val="300"/>
               </a:spcAft>
@@ -8179,6 +8512,9 @@
           <a:lstStyle/>
           <a:p>
             <a:pPr indent="0" marL="0">
+              <a:lnSpc>
+                <a:spcPts val="1500"/>
+              </a:lnSpc>
               <a:buNone/>
             </a:pPr>
             <a:r>
@@ -8242,6 +8578,9 @@
           <a:lstStyle/>
           <a:p>
             <a:pPr indent="0" marL="0">
+              <a:lnSpc>
+                <a:spcPts val="1500"/>
+              </a:lnSpc>
               <a:buNone/>
             </a:pPr>
             <a:r>
@@ -8278,6 +8617,9 @@
           <a:lstStyle/>
           <a:p>
             <a:pPr indent="0" marL="0">
+              <a:lnSpc>
+                <a:spcPts val="2300"/>
+              </a:lnSpc>
               <a:buNone/>
             </a:pPr>
             <a:r>
@@ -8314,6 +8656,9 @@
           <a:lstStyle/>
           <a:p>
             <a:pPr marL="342900" indent="-342900">
+              <a:lnSpc>
+                <a:spcPts val="1600"/>
+              </a:lnSpc>
               <a:spcAft>
                 <a:spcPts val="300"/>
               </a:spcAft>
@@ -8332,6 +8677,9 @@
           </a:p>
           <a:p>
             <a:pPr marL="342900" indent="-342900">
+              <a:lnSpc>
+                <a:spcPts val="1600"/>
+              </a:lnSpc>
               <a:spcAft>
                 <a:spcPts val="300"/>
               </a:spcAft>
@@ -8350,6 +8698,9 @@
           </a:p>
           <a:p>
             <a:pPr marL="342900" indent="-342900">
+              <a:lnSpc>
+                <a:spcPts val="1600"/>
+              </a:lnSpc>
               <a:spcAft>
                 <a:spcPts val="300"/>
               </a:spcAft>
@@ -8368,6 +8719,9 @@
           </a:p>
           <a:p>
             <a:pPr marL="342900" indent="-342900">
+              <a:lnSpc>
+                <a:spcPts val="1600"/>
+              </a:lnSpc>
               <a:spcAft>
                 <a:spcPts val="300"/>
               </a:spcAft>
@@ -8408,6 +8762,9 @@
           <a:lstStyle/>
           <a:p>
             <a:pPr indent="0" marL="0">
+              <a:lnSpc>
+                <a:spcPts val="1500"/>
+              </a:lnSpc>
               <a:buNone/>
             </a:pPr>
             <a:r>
@@ -8471,6 +8828,9 @@
           <a:lstStyle/>
           <a:p>
             <a:pPr indent="0" marL="0">
+              <a:lnSpc>
+                <a:spcPts val="1500"/>
+              </a:lnSpc>
               <a:buNone/>
             </a:pPr>
             <a:r>
@@ -8507,6 +8867,9 @@
           <a:lstStyle/>
           <a:p>
             <a:pPr indent="0" marL="0">
+              <a:lnSpc>
+                <a:spcPts val="2300"/>
+              </a:lnSpc>
               <a:buNone/>
             </a:pPr>
             <a:r>
@@ -8543,6 +8906,9 @@
           <a:lstStyle/>
           <a:p>
             <a:pPr marL="342900" indent="-342900">
+              <a:lnSpc>
+                <a:spcPts val="1600"/>
+              </a:lnSpc>
               <a:spcAft>
                 <a:spcPts val="300"/>
               </a:spcAft>
@@ -8561,6 +8927,9 @@
           </a:p>
           <a:p>
             <a:pPr marL="342900" indent="-342900">
+              <a:lnSpc>
+                <a:spcPts val="1600"/>
+              </a:lnSpc>
               <a:spcAft>
                 <a:spcPts val="300"/>
               </a:spcAft>
@@ -8579,6 +8948,9 @@
           </a:p>
           <a:p>
             <a:pPr marL="342900" indent="-342900">
+              <a:lnSpc>
+                <a:spcPts val="1600"/>
+              </a:lnSpc>
               <a:spcAft>
                 <a:spcPts val="300"/>
               </a:spcAft>
@@ -8597,6 +8969,9 @@
           </a:p>
           <a:p>
             <a:pPr marL="342900" indent="-342900">
+              <a:lnSpc>
+                <a:spcPts val="1600"/>
+              </a:lnSpc>
               <a:spcAft>
                 <a:spcPts val="300"/>
               </a:spcAft>
@@ -8637,6 +9012,9 @@
           <a:lstStyle/>
           <a:p>
             <a:pPr indent="0" marL="0">
+              <a:lnSpc>
+                <a:spcPts val="1500"/>
+              </a:lnSpc>
               <a:buNone/>
             </a:pPr>
             <a:r>
@@ -8745,6 +9123,9 @@
           <a:lstStyle/>
           <a:p>
             <a:pPr indent="0" marL="0">
+              <a:lnSpc>
+                <a:spcPts val="3400"/>
+              </a:lnSpc>
               <a:buNone/>
             </a:pPr>
             <a:r>
@@ -8808,6 +9189,9 @@
           <a:lstStyle/>
           <a:p>
             <a:pPr indent="0" marL="0">
+              <a:lnSpc>
+                <a:spcPts val="1500"/>
+              </a:lnSpc>
               <a:buNone/>
             </a:pPr>
             <a:r>
@@ -8844,6 +9228,9 @@
           <a:lstStyle/>
           <a:p>
             <a:pPr indent="0" marL="0">
+              <a:lnSpc>
+                <a:spcPts val="2000"/>
+              </a:lnSpc>
               <a:buNone/>
             </a:pPr>
             <a:r>
@@ -8880,6 +9267,9 @@
           <a:lstStyle/>
           <a:p>
             <a:pPr indent="0" marL="0">
+              <a:lnSpc>
+                <a:spcPts val="1600"/>
+              </a:lnSpc>
               <a:buNone/>
             </a:pPr>
             <a:r>
@@ -8943,6 +9333,9 @@
           <a:lstStyle/>
           <a:p>
             <a:pPr algn="ctr" indent="0" marL="0">
+              <a:lnSpc>
+                <a:spcPts val="1500"/>
+              </a:lnSpc>
               <a:buNone/>
             </a:pPr>
             <a:r>
@@ -9006,6 +9399,9 @@
           <a:lstStyle/>
           <a:p>
             <a:pPr indent="0" marL="0">
+              <a:lnSpc>
+                <a:spcPts val="1500"/>
+              </a:lnSpc>
               <a:buNone/>
             </a:pPr>
             <a:r>
@@ -9042,6 +9438,9 @@
           <a:lstStyle/>
           <a:p>
             <a:pPr indent="0" marL="0">
+              <a:lnSpc>
+                <a:spcPts val="2000"/>
+              </a:lnSpc>
               <a:buNone/>
             </a:pPr>
             <a:r>
@@ -9078,6 +9477,9 @@
           <a:lstStyle/>
           <a:p>
             <a:pPr indent="0" marL="0">
+              <a:lnSpc>
+                <a:spcPts val="1600"/>
+              </a:lnSpc>
               <a:buNone/>
             </a:pPr>
             <a:r>
@@ -9141,6 +9543,9 @@
           <a:lstStyle/>
           <a:p>
             <a:pPr indent="0" marL="0">
+              <a:lnSpc>
+                <a:spcPts val="1500"/>
+              </a:lnSpc>
               <a:buNone/>
             </a:pPr>
             <a:r>
@@ -9177,6 +9582,9 @@
           <a:lstStyle/>
           <a:p>
             <a:pPr indent="0" marL="0">
+              <a:lnSpc>
+                <a:spcPts val="2000"/>
+              </a:lnSpc>
               <a:buNone/>
             </a:pPr>
             <a:r>
@@ -9213,6 +9621,9 @@
           <a:lstStyle/>
           <a:p>
             <a:pPr indent="0" marL="0">
+              <a:lnSpc>
+                <a:spcPts val="1600"/>
+              </a:lnSpc>
               <a:buNone/>
             </a:pPr>
             <a:r>
@@ -9249,6 +9660,9 @@
           <a:lstStyle/>
           <a:p>
             <a:pPr indent="0" marL="0">
+              <a:lnSpc>
+                <a:spcPts val="1500"/>
+              </a:lnSpc>
               <a:buNone/>
             </a:pPr>
             <a:r>
@@ -9357,6 +9771,9 @@
           <a:lstStyle/>
           <a:p>
             <a:pPr indent="0" marL="0">
+              <a:lnSpc>
+                <a:spcPts val="3400"/>
+              </a:lnSpc>
               <a:buNone/>
             </a:pPr>
             <a:r>
@@ -9393,6 +9810,9 @@
           <a:lstStyle/>
           <a:p>
             <a:pPr indent="0" marL="0">
+              <a:lnSpc>
+                <a:spcPts val="3800"/>
+              </a:lnSpc>
               <a:buNone/>
             </a:pPr>
             <a:r>
@@ -9429,6 +9849,9 @@
           <a:lstStyle/>
           <a:p>
             <a:pPr indent="0" marL="0">
+              <a:lnSpc>
+                <a:spcPts val="1500"/>
+              </a:lnSpc>
               <a:buNone/>
             </a:pPr>
             <a:r>
@@ -9465,6 +9888,9 @@
           <a:lstStyle/>
           <a:p>
             <a:pPr indent="0" marL="0">
+              <a:lnSpc>
+                <a:spcPts val="3800"/>
+              </a:lnSpc>
               <a:buNone/>
             </a:pPr>
             <a:r>
@@ -9501,6 +9927,9 @@
           <a:lstStyle/>
           <a:p>
             <a:pPr indent="0" marL="0">
+              <a:lnSpc>
+                <a:spcPts val="1500"/>
+              </a:lnSpc>
               <a:buNone/>
             </a:pPr>
             <a:r>
@@ -9537,6 +9966,9 @@
           <a:lstStyle/>
           <a:p>
             <a:pPr indent="0" marL="0">
+              <a:lnSpc>
+                <a:spcPts val="3800"/>
+              </a:lnSpc>
               <a:buNone/>
             </a:pPr>
             <a:r>
@@ -9573,6 +10005,9 @@
           <a:lstStyle/>
           <a:p>
             <a:pPr indent="0" marL="0">
+              <a:lnSpc>
+                <a:spcPts val="1500"/>
+              </a:lnSpc>
               <a:buNone/>
             </a:pPr>
             <a:r>
@@ -9595,8 +10030,8 @@
         </p:nvSpPr>
         <p:spPr>
           <a:xfrm>
-            <a:off x="457200" y="3749040"/>
-            <a:ext cx="3017520" cy="822960"/>
+            <a:off x="457200" y="3703320"/>
+            <a:ext cx="3017520" cy="914400"/>
           </a:xfrm>
           <a:prstGeom prst="rect">
             <a:avLst/>
@@ -9609,6 +10044,9 @@
           <a:lstStyle/>
           <a:p>
             <a:pPr indent="0" marL="0">
+              <a:lnSpc>
+                <a:spcPts val="1400"/>
+              </a:lnSpc>
               <a:buNone/>
             </a:pPr>
             <a:r>
@@ -9617,7 +10055,7 @@
                   <a:schemeClr val="accent5"/>
                 </a:solidFill>
               </a:rPr>
-              <a:t>假設：8 間 × ¥680 × 45% × 30 天；其他收入 ¥12,000；營運成本 ¥65,000。尚未含折舊、利息、稅與業主薪酬。</a:t>
+              <a:t>假設：8 間 × ¥680 × 45% × 30 天；其他收入 ¥12,000；營運成本 ¥65,000。尚未含折舊、利息、稅與業主薪酬。損益平衡＝(65,000−12,000)÷163,200。</a:t>
             </a:r>
             <a:endParaRPr lang="en-US" sz="1100" dirty="0"/>
           </a:p>
@@ -9661,6 +10099,9 @@
           <a:lstStyle/>
           <a:p>
             <a:pPr indent="0" marL="0">
+              <a:lnSpc>
+                <a:spcPts val="1600"/>
+              </a:lnSpc>
               <a:buNone/>
             </a:pPr>
             <a:r>
@@ -9669,7 +10110,7 @@
                   <a:schemeClr val="accent3"/>
                 </a:solidFill>
               </a:rPr>
-              <a:t>損益平衡入住率約 32.5%（(65,000 − 12,000) ÷ 163,200）</a:t>
+              <a:t>損益平衡入住率約 32.5%</a:t>
             </a:r>
             <a:endParaRPr lang="en-US" sz="1300" dirty="0"/>
           </a:p>

</xml_diff>

<commit_message>
Healing hotel deck: 15-20 rooms, mountain/water landscape slide, drop medical footnote
Co-Authored-By: Claude Opus 5.5 <noreply@anthropic.com>
Claude-Session: https://claude.ai/code/session_019koV41QHXrLyXuEfvuae5F
</commit_message>
<xml_diff>
--- a/康復療癒酒店整體設計規劃.pptx
+++ b/康復療癒酒店整體設計規劃.pptx
@@ -17,9 +17,10 @@
     <p:sldId id="265" r:id="rId11"/>
     <p:sldId id="266" r:id="rId12"/>
     <p:sldId id="267" r:id="rId13"/>
+    <p:sldId id="268" r:id="rId14"/>
   </p:sldIdLst>
   <p:notesMasterIdLst>
-    <p:notesMasterId r:id="rId14"/>
+    <p:notesMasterId r:id="rId15"/>
   </p:notesMasterIdLst>
   <p:sldSz cx="9144000" cy="5143500"/>
   <p:notesSz cx="5143500" cy="9144000"/>
@@ -118,40 +119,41 @@
   <p:extLst>
     <p:ext uri="{521415D9-36F7-43E2-AB2F-B90AF26B5E84}">
       <p14:sectionLst xmlns:p14="http://schemas.microsoft.com/office/powerpoint/2010/main">
-        <p14:section name="開場" id="{eeb361df-8729-6cf6-1289-02bc3550e254}">
+        <p14:section name="開場" id="{44cc793a-0c94-3fb5-0a6d-48a4f99adfd6}">
           <p14:sldIdLst>
             <p14:sldId id="256"/>
           </p14:sldIdLst>
         </p14:section>
-        <p14:section name="定位" id="{77af16d0-a66a-66ee-919a-7416422463c5}">
+        <p14:section name="定位" id="{46d26de9-7962-5d0c-2fa7-a46fd0884c42}">
           <p14:sldIdLst>
             <p14:sldId id="257"/>
             <p14:sldId id="258"/>
             <p14:sldId id="259"/>
           </p14:sldIdLst>
         </p14:section>
-        <p14:section name="空間與服務" id="{0cd7e448-0afc-3d1f-c91c-38510a793257}">
+        <p14:section name="空間與服務" id="{c654ee90-74c5-2333-f2c6-cadd9be1e011}">
           <p14:sldIdLst>
             <p14:sldId id="260"/>
             <p14:sldId id="261"/>
           </p14:sldIdLst>
         </p14:section>
-        <p14:section name="品牌與客群" id="{f0b65bdb-b3f3-99fe-cf4b-edf90bd24e48}">
+        <p14:section name="品牌與客群" id="{e77aebea-9f6d-8711-51a6-242e82e9556e}">
           <p14:sldIdLst>
             <p14:sldId id="262"/>
             <p14:sldId id="263"/>
           </p14:sldIdLst>
         </p14:section>
-        <p14:section name="療程設計" id="{f8925866-a920-8fab-e3c7-ac5d5a186ee3}">
+        <p14:section name="療程設計" id="{fdf08d86-e546-7fda-e54e-037c78c9ec51}">
           <p14:sldIdLst>
             <p14:sldId id="264"/>
             <p14:sldId id="265"/>
             <p14:sldId id="266"/>
+            <p14:sldId id="267"/>
           </p14:sldIdLst>
         </p14:section>
-        <p14:section name="合作價值" id="{b5770f3a-f332-6b32-e1ff-5c1c0407c50f}">
+        <p14:section name="合作價值" id="{4ebc06b0-b144-a7b7-afc9-808214474af6}">
           <p14:sldIdLst>
-            <p14:sldId id="267"/>
+            <p14:sldId id="268"/>
           </p14:sldIdLst>
         </p14:section>
       </p14:sectionLst>
@@ -558,7 +560,7 @@
           <a:p>
             <a:r>
               <a:rPr lang="en-US" dirty="0"/>
-              <a:t>本簡報整理康復療癒酒店的定位、空間、服務、產品、成本、損益、合規與開業順序。</a:t>
+              <a:t>本提案整理康復療癒酒店的定位、空間、服務、品牌、客群、十大療癒模組、山水地景、個人化流程與五天四夜行程。</a:t>
             </a:r>
             <a:endParaRPr lang="en-US" dirty="0"/>
           </a:p>
@@ -846,6 +848,94 @@
             <a:fld id="{F7021451-1387-4CA6-816F-3879F97B5CBC}" type="slidenum">
               <a:rPr lang="en-US"/>
               <a:t>12</a:t>
+            </a:fld>
+            <a:endParaRPr lang="en-US"/>
+          </a:p>
+        </p:txBody>
+      </p:sp>
+    </p:spTree>
+    <p:extLst>
+      <p:ext uri="{BB962C8B-B14F-4D97-AF65-F5344CB8AC3E}">
+        <p14:creationId xmlns:p14="http://schemas.microsoft.com/office/powerpoint/2010/main" val="1024086991"/>
+      </p:ext>
+    </p:extLst>
+  </p:cSld>
+  <p:clrMapOvr>
+    <a:masterClrMapping/>
+  </p:clrMapOvr>
+</p:notes>
+</file>
+
+<file path=ppt/notesSlides/notesSlide13.xml><?xml version="1.0" encoding="utf-8"?>
+<p:notes xmlns:a="http://schemas.openxmlformats.org/drawingml/2006/main" xmlns:r="http://schemas.openxmlformats.org/officeDocument/2006/relationships" xmlns:p="http://schemas.openxmlformats.org/presentationml/2006/main">
+  <p:cSld>
+    <p:spTree>
+      <p:nvGrpSpPr>
+        <p:cNvPr id="1" name=""/>
+        <p:cNvGrpSpPr/>
+        <p:nvPr/>
+      </p:nvGrpSpPr>
+      <p:grpSpPr>
+        <a:xfrm>
+          <a:off x="0" y="0"/>
+          <a:ext cx="0" cy="0"/>
+          <a:chOff x="0" y="0"/>
+          <a:chExt cx="0" cy="0"/>
+        </a:xfrm>
+      </p:grpSpPr>
+      <p:sp>
+        <p:nvSpPr>
+          <p:cNvPr id="2" name="Slide Image Placeholder 1"/>
+          <p:cNvSpPr>
+            <a:spLocks noGrp="1" noRot="1" noChangeAspect="1"/>
+          </p:cNvSpPr>
+          <p:nvPr>
+            <p:ph type="sldImg"/>
+          </p:nvPr>
+        </p:nvSpPr>
+        <p:spPr/>
+      </p:sp>
+      <p:sp>
+        <p:nvSpPr>
+          <p:cNvPr id="3" name="Notes Placeholder 2"/>
+          <p:cNvSpPr>
+            <a:spLocks noGrp="1"/>
+          </p:cNvSpPr>
+          <p:nvPr>
+            <p:ph type="body" idx="1"/>
+          </p:nvPr>
+        </p:nvSpPr>
+        <p:spPr/>
+        <p:txBody>
+          <a:bodyPr/>
+          <a:lstStyle/>
+          <a:p>
+            <a:r>
+              <a:rPr lang="en-US" dirty="0"/>
+              <a:t/>
+            </a:r>
+            <a:endParaRPr lang="en-US" dirty="0"/>
+          </a:p>
+        </p:txBody>
+      </p:sp>
+      <p:sp>
+        <p:nvSpPr>
+          <p:cNvPr id="4" name="Slide Number Placeholder 3"/>
+          <p:cNvSpPr>
+            <a:spLocks noGrp="1"/>
+          </p:cNvSpPr>
+          <p:nvPr>
+            <p:ph type="sldNum" sz="quarter" idx="10"/>
+          </p:nvPr>
+        </p:nvSpPr>
+        <p:spPr/>
+        <p:txBody>
+          <a:bodyPr/>
+          <a:lstStyle/>
+          <a:p>
+            <a:fld id="{F7021451-1387-4CA6-816F-3879F97B5CBC}" type="slidenum">
+              <a:rPr lang="en-US"/>
+              <a:t>13</a:t>
             </a:fld>
             <a:endParaRPr lang="en-US"/>
           </a:p>
@@ -2427,7 +2517,7 @@
                   <a:schemeClr val="tx2"/>
                 </a:solidFill>
               </a:rPr>
-              <a:t>個人化方式：前測 → 後測 → 五日健康報告</a:t>
+              <a:t>山水地景 × 十療：相輔相乘</a:t>
             </a:r>
             <a:endParaRPr lang="en-US" sz="2800" dirty="0"/>
           </a:p>
@@ -2435,14 +2525,80 @@
       </p:sp>
       <p:sp>
         <p:nvSpPr>
-          <p:cNvPr id="3" name="入住前測 circle"/>
+          <p:cNvPr id="3" name="Text 1"/>
+          <p:cNvSpPr txBox="1"/>
+          <p:nvPr/>
+        </p:nvSpPr>
+        <p:spPr>
+          <a:xfrm>
+            <a:off x="457200" y="914400"/>
+            <a:ext cx="8229600" cy="320040"/>
+          </a:xfrm>
+          <a:prstGeom prst="rect">
+            <a:avLst/>
+          </a:prstGeom>
+          <a:noFill/>
+          <a:ln/>
+        </p:spPr>
+        <p:txBody>
+          <a:bodyPr wrap="square" lIns="0" tIns="0" rIns="0" bIns="0" rtlCol="0" anchor="t"/>
+          <a:lstStyle/>
+          <a:p>
+            <a:pPr indent="0" marL="0">
+              <a:lnSpc>
+                <a:spcPts val="1600"/>
+              </a:lnSpc>
+              <a:buNone/>
+            </a:pPr>
+            <a:r>
+              <a:rPr lang="en-US" sz="1300" dirty="0">
+                <a:solidFill>
+                  <a:schemeClr val="accent5"/>
+                </a:solidFill>
+              </a:rPr>
+              <a:t>地景提供療癒場域，十療提供方法——兩者結合，效果與體驗都放大</a:t>
+            </a:r>
+            <a:endParaRPr lang="en-US" sz="1300" dirty="0"/>
+          </a:p>
+        </p:txBody>
+      </p:sp>
+      <p:sp>
+        <p:nvSpPr>
+          <p:cNvPr id="4" name="山・山居療癒"/>
           <p:cNvSpPr/>
           <p:nvPr/>
         </p:nvSpPr>
         <p:spPr>
           <a:xfrm>
-            <a:off x="1005840" y="1234440"/>
-            <a:ext cx="777240" cy="777240"/>
+            <a:off x="457200" y="1325880"/>
+            <a:ext cx="4023360" cy="2514600"/>
+          </a:xfrm>
+          <a:prstGeom prst="roundRect">
+            <a:avLst>
+              <a:gd name="adj" fmla="val 2909"/>
+            </a:avLst>
+          </a:prstGeom>
+          <a:solidFill>
+            <a:srgbClr val="EEF3EC"/>
+          </a:solidFill>
+          <a:ln w="12700">
+            <a:solidFill>
+              <a:srgbClr val="EEF3EC"/>
+            </a:solidFill>
+            <a:prstDash val="solid"/>
+          </a:ln>
+        </p:spPr>
+      </p:sp>
+      <p:sp>
+        <p:nvSpPr>
+          <p:cNvPr id="5" name="山・山居療癒 circle"/>
+          <p:cNvSpPr/>
+          <p:nvPr/>
+        </p:nvSpPr>
+        <p:spPr>
+          <a:xfrm>
+            <a:off x="685800" y="1463040"/>
+            <a:ext cx="548640" cy="548640"/>
           </a:xfrm>
           <a:prstGeom prst="ellipse">
             <a:avLst/>
@@ -2460,7 +2616,7 @@
       </p:sp>
       <p:pic>
         <p:nvPicPr>
-          <p:cNvPr id="4" name="入住前測 icon" descr="入住前測">    </p:cNvPr>
+          <p:cNvPr id="6" name="山・山居療癒 icon" descr="山・山居療癒">    </p:cNvPr>
           <p:cNvPicPr>
             <a:picLocks noChangeAspect="1"/>
           </p:cNvPicPr>
@@ -2474,48 +2630,24 @@
         </p:blipFill>
         <p:spPr>
           <a:xfrm>
-            <a:off x="1200150" y="1428750"/>
-            <a:ext cx="388620" cy="388620"/>
+            <a:off x="822960" y="1600200"/>
+            <a:ext cx="274320" cy="274320"/>
           </a:xfrm>
           <a:prstGeom prst="rect">
             <a:avLst/>
           </a:prstGeom>
         </p:spPr>
       </p:pic>
-      <p:pic>
-        <p:nvPicPr>
-          <p:cNvPr id="5" name="Arrow 1" descr="next">    </p:cNvPr>
-          <p:cNvPicPr>
-            <a:picLocks noChangeAspect="1"/>
-          </p:cNvPicPr>
-          <p:nvPr/>
-        </p:nvPicPr>
-        <p:blipFill>
-          <a:blip r:embed="rId2"/>
-          <a:stretch>
-            <a:fillRect/>
-          </a:stretch>
-        </p:blipFill>
-        <p:spPr>
-          <a:xfrm>
-            <a:off x="2148840" y="1463040"/>
-            <a:ext cx="320040" cy="320040"/>
-          </a:xfrm>
-          <a:prstGeom prst="rect">
-            <a:avLst/>
-          </a:prstGeom>
-        </p:spPr>
-      </p:pic>
-      <p:sp>
-        <p:nvSpPr>
-          <p:cNvPr id="6" name="Text 2"/>
+      <p:sp>
+        <p:nvSpPr>
+          <p:cNvPr id="7" name="Text 4"/>
           <p:cNvSpPr txBox="1"/>
           <p:nvPr/>
         </p:nvSpPr>
         <p:spPr>
           <a:xfrm>
-            <a:off x="457200" y="2148840"/>
-            <a:ext cx="1874520" cy="365760"/>
+            <a:off x="1371600" y="1572768"/>
+            <a:ext cx="2926080" cy="365760"/>
           </a:xfrm>
           <a:prstGeom prst="rect">
             <a:avLst/>
@@ -2527,76 +2659,39 @@
           <a:bodyPr wrap="square" lIns="0" tIns="0" rIns="0" bIns="0" rtlCol="0" anchor="t"/>
           <a:lstStyle/>
           <a:p>
-            <a:pPr algn="ctr" indent="0" marL="0">
-              <a:lnSpc>
-                <a:spcPts val="2000"/>
-              </a:lnSpc>
-              <a:buNone/>
-            </a:pPr>
-            <a:r>
-              <a:rPr lang="en-US" sz="1600" b="1" dirty="0">
+            <a:pPr indent="0" marL="0">
+              <a:lnSpc>
+                <a:spcPts val="2100"/>
+              </a:lnSpc>
+              <a:buNone/>
+            </a:pPr>
+            <a:r>
+              <a:rPr lang="en-US" sz="1700" b="1" dirty="0">
                 <a:solidFill>
                   <a:schemeClr val="tx2"/>
                 </a:solidFill>
               </a:rPr>
-              <a:t>入住前測</a:t>
-            </a:r>
-            <a:endParaRPr lang="en-US" sz="1600" dirty="0"/>
-          </a:p>
-        </p:txBody>
-      </p:sp>
-      <p:sp>
-        <p:nvSpPr>
-          <p:cNvPr id="7" name="Text 3"/>
-          <p:cNvSpPr txBox="1"/>
-          <p:nvPr/>
-        </p:nvSpPr>
-        <p:spPr>
-          <a:xfrm>
-            <a:off x="548640" y="2560320"/>
-            <a:ext cx="1691640" cy="777240"/>
-          </a:xfrm>
-          <a:prstGeom prst="rect">
-            <a:avLst/>
-          </a:prstGeom>
-          <a:noFill/>
-          <a:ln/>
-        </p:spPr>
-        <p:txBody>
-          <a:bodyPr wrap="square" lIns="0" tIns="0" rIns="0" bIns="0" rtlCol="0" anchor="t"/>
-          <a:lstStyle/>
-          <a:p>
-            <a:pPr indent="0" marL="0">
-              <a:lnSpc>
-                <a:spcPts val="1500"/>
-              </a:lnSpc>
-              <a:buNone/>
-            </a:pPr>
-            <a:r>
-              <a:rPr lang="en-US" sz="1200" dirty="0">
-                <a:solidFill>
-                  <a:schemeClr val="tx1"/>
-                </a:solidFill>
-              </a:rPr>
-              <a:t>血壓、血糖、體組成、睡眠問卷、九大體質判定</a:t>
-            </a:r>
-            <a:endParaRPr lang="en-US" sz="1200" dirty="0"/>
-          </a:p>
-        </p:txBody>
-      </p:sp>
-      <p:sp>
-        <p:nvSpPr>
-          <p:cNvPr id="8" name="配對組合 circle"/>
+              <a:t>山・山居療癒</a:t>
+            </a:r>
+            <a:endParaRPr lang="en-US" sz="1700" dirty="0"/>
+          </a:p>
+        </p:txBody>
+      </p:sp>
+      <p:sp>
+        <p:nvSpPr>
+          <p:cNvPr id="8" name="山・山居療癒 tag 1"/>
           <p:cNvSpPr/>
           <p:nvPr/>
         </p:nvSpPr>
         <p:spPr>
           <a:xfrm>
-            <a:off x="3108960" y="1234440"/>
-            <a:ext cx="777240" cy="777240"/>
-          </a:xfrm>
-          <a:prstGeom prst="ellipse">
-            <a:avLst/>
+            <a:off x="685800" y="2194560"/>
+            <a:ext cx="1005840" cy="292608"/>
+          </a:xfrm>
+          <a:prstGeom prst="roundRect">
+            <a:avLst>
+              <a:gd name="adj" fmla="val 50000"/>
+            </a:avLst>
           </a:prstGeom>
           <a:solidFill>
             <a:srgbClr val="2F4A3A"/>
@@ -2609,145 +2704,99 @@
           </a:ln>
         </p:spPr>
       </p:sp>
-      <p:pic>
-        <p:nvPicPr>
-          <p:cNvPr id="9" name="配對組合 icon" descr="配對組合">    </p:cNvPr>
-          <p:cNvPicPr>
-            <a:picLocks noChangeAspect="1"/>
-          </p:cNvPicPr>
-          <p:nvPr/>
-        </p:nvPicPr>
-        <p:blipFill>
-          <a:blip r:embed="rId3"/>
-          <a:stretch>
-            <a:fillRect/>
-          </a:stretch>
-        </p:blipFill>
-        <p:spPr>
-          <a:xfrm>
-            <a:off x="3303270" y="1428750"/>
-            <a:ext cx="388620" cy="388620"/>
-          </a:xfrm>
-          <a:prstGeom prst="rect">
-            <a:avLst/>
-          </a:prstGeom>
-        </p:spPr>
-      </p:pic>
-      <p:pic>
-        <p:nvPicPr>
-          <p:cNvPr id="10" name="Arrow 2" descr="next">    </p:cNvPr>
-          <p:cNvPicPr>
-            <a:picLocks noChangeAspect="1"/>
-          </p:cNvPicPr>
-          <p:nvPr/>
-        </p:nvPicPr>
-        <p:blipFill>
-          <a:blip r:embed="rId4"/>
-          <a:stretch>
-            <a:fillRect/>
-          </a:stretch>
-        </p:blipFill>
-        <p:spPr>
-          <a:xfrm>
-            <a:off x="4251960" y="1463040"/>
-            <a:ext cx="320040" cy="320040"/>
-          </a:xfrm>
-          <a:prstGeom prst="rect">
-            <a:avLst/>
-          </a:prstGeom>
-        </p:spPr>
-      </p:pic>
-      <p:sp>
-        <p:nvSpPr>
-          <p:cNvPr id="11" name="Text 5"/>
+      <p:sp>
+        <p:nvSpPr>
+          <p:cNvPr id="9" name="Text 6"/>
           <p:cNvSpPr txBox="1"/>
           <p:nvPr/>
         </p:nvSpPr>
         <p:spPr>
           <a:xfrm>
-            <a:off x="2560320" y="2148840"/>
-            <a:ext cx="1874520" cy="365760"/>
-          </a:xfrm>
-          <a:prstGeom prst="rect">
-            <a:avLst/>
-          </a:prstGeom>
-          <a:noFill/>
-          <a:ln/>
-        </p:spPr>
-        <p:txBody>
-          <a:bodyPr wrap="square" lIns="0" tIns="0" rIns="0" bIns="0" rtlCol="0" anchor="t"/>
+            <a:off x="685800" y="2194560"/>
+            <a:ext cx="1005840" cy="292608"/>
+          </a:xfrm>
+          <a:prstGeom prst="rect">
+            <a:avLst/>
+          </a:prstGeom>
+          <a:noFill/>
+          <a:ln/>
+        </p:spPr>
+        <p:txBody>
+          <a:bodyPr wrap="square" lIns="0" tIns="0" rIns="0" bIns="0" rtlCol="0" anchor="ctr"/>
           <a:lstStyle/>
           <a:p>
             <a:pPr algn="ctr" indent="0" marL="0">
               <a:lnSpc>
-                <a:spcPts val="2000"/>
-              </a:lnSpc>
-              <a:buNone/>
-            </a:pPr>
-            <a:r>
-              <a:rPr lang="en-US" sz="1600" b="1" dirty="0">
-                <a:solidFill>
-                  <a:schemeClr val="tx2"/>
-                </a:solidFill>
-              </a:rPr>
-              <a:t>配對組合</a:t>
-            </a:r>
-            <a:endParaRPr lang="en-US" sz="1600" dirty="0"/>
-          </a:p>
-        </p:txBody>
-      </p:sp>
-      <p:sp>
-        <p:nvSpPr>
-          <p:cNvPr id="12" name="Text 6"/>
+                <a:spcPts val="1400"/>
+              </a:lnSpc>
+              <a:buNone/>
+            </a:pPr>
+            <a:r>
+              <a:rPr lang="en-US" sz="1100" b="1" dirty="0">
+                <a:solidFill>
+                  <a:schemeClr val="bg1"/>
+                </a:solidFill>
+              </a:rPr>
+              <a:t>自然療癒</a:t>
+            </a:r>
+            <a:endParaRPr lang="en-US" sz="1100" dirty="0"/>
+          </a:p>
+        </p:txBody>
+      </p:sp>
+      <p:sp>
+        <p:nvSpPr>
+          <p:cNvPr id="10" name="Text 7"/>
           <p:cNvSpPr txBox="1"/>
           <p:nvPr/>
         </p:nvSpPr>
         <p:spPr>
           <a:xfrm>
-            <a:off x="2651760" y="2560320"/>
-            <a:ext cx="1691640" cy="777240"/>
-          </a:xfrm>
-          <a:prstGeom prst="rect">
-            <a:avLst/>
-          </a:prstGeom>
-          <a:noFill/>
-          <a:ln/>
-        </p:spPr>
-        <p:txBody>
-          <a:bodyPr wrap="square" lIns="0" tIns="0" rIns="0" bIns="0" rtlCol="0" anchor="t"/>
+            <a:off x="1828800" y="2194560"/>
+            <a:ext cx="2514600" cy="292608"/>
+          </a:xfrm>
+          <a:prstGeom prst="rect">
+            <a:avLst/>
+          </a:prstGeom>
+          <a:noFill/>
+          <a:ln/>
+        </p:spPr>
+        <p:txBody>
+          <a:bodyPr wrap="square" lIns="0" tIns="0" rIns="0" bIns="0" rtlCol="0" anchor="ctr"/>
           <a:lstStyle/>
           <a:p>
             <a:pPr indent="0" marL="0">
               <a:lnSpc>
-                <a:spcPts val="1500"/>
-              </a:lnSpc>
-              <a:buNone/>
-            </a:pPr>
-            <a:r>
-              <a:rPr lang="en-US" sz="1200" dirty="0">
+                <a:spcPts val="1600"/>
+              </a:lnSpc>
+              <a:buNone/>
+            </a:pPr>
+            <a:r>
+              <a:rPr lang="en-US" sz="1300" dirty="0">
                 <a:solidFill>
                   <a:schemeClr val="tx1"/>
                 </a:solidFill>
               </a:rPr>
-              <a:t>依評估結果，從十大模組配對個人化療程</a:t>
-            </a:r>
-            <a:endParaRPr lang="en-US" sz="1200" dirty="0"/>
-          </a:p>
-        </p:txBody>
-      </p:sp>
-      <p:sp>
-        <p:nvSpPr>
-          <p:cNvPr id="13" name="五日療程 circle"/>
+              <a:t>森林步道、林間太極與八段錦</a:t>
+            </a:r>
+            <a:endParaRPr lang="en-US" sz="1300" dirty="0"/>
+          </a:p>
+        </p:txBody>
+      </p:sp>
+      <p:sp>
+        <p:nvSpPr>
+          <p:cNvPr id="11" name="山・山居療癒 tag 2"/>
           <p:cNvSpPr/>
           <p:nvPr/>
         </p:nvSpPr>
         <p:spPr>
           <a:xfrm>
-            <a:off x="5212080" y="1234440"/>
-            <a:ext cx="777240" cy="777240"/>
-          </a:xfrm>
-          <a:prstGeom prst="ellipse">
-            <a:avLst/>
+            <a:off x="685800" y="2596896"/>
+            <a:ext cx="1005840" cy="292608"/>
+          </a:xfrm>
+          <a:prstGeom prst="roundRect">
+            <a:avLst>
+              <a:gd name="adj" fmla="val 50000"/>
+            </a:avLst>
           </a:prstGeom>
           <a:solidFill>
             <a:srgbClr val="2F4A3A"/>
@@ -2760,273 +2809,98 @@
           </a:ln>
         </p:spPr>
       </p:sp>
-      <p:pic>
-        <p:nvPicPr>
-          <p:cNvPr id="14" name="五日療程 icon" descr="五日療程">    </p:cNvPr>
-          <p:cNvPicPr>
-            <a:picLocks noChangeAspect="1"/>
-          </p:cNvPicPr>
-          <p:nvPr/>
-        </p:nvPicPr>
-        <p:blipFill>
-          <a:blip r:embed="rId5"/>
-          <a:stretch>
-            <a:fillRect/>
-          </a:stretch>
-        </p:blipFill>
-        <p:spPr>
-          <a:xfrm>
-            <a:off x="5406390" y="1428750"/>
-            <a:ext cx="388620" cy="388620"/>
-          </a:xfrm>
-          <a:prstGeom prst="rect">
-            <a:avLst/>
-          </a:prstGeom>
-        </p:spPr>
-      </p:pic>
-      <p:pic>
-        <p:nvPicPr>
-          <p:cNvPr id="15" name="Arrow 3" descr="next">    </p:cNvPr>
-          <p:cNvPicPr>
-            <a:picLocks noChangeAspect="1"/>
-          </p:cNvPicPr>
-          <p:nvPr/>
-        </p:nvPicPr>
-        <p:blipFill>
-          <a:blip r:embed="rId6"/>
-          <a:stretch>
-            <a:fillRect/>
-          </a:stretch>
-        </p:blipFill>
-        <p:spPr>
-          <a:xfrm>
-            <a:off x="6355080" y="1463040"/>
-            <a:ext cx="320040" cy="320040"/>
-          </a:xfrm>
-          <a:prstGeom prst="rect">
-            <a:avLst/>
-          </a:prstGeom>
-        </p:spPr>
-      </p:pic>
-      <p:sp>
-        <p:nvSpPr>
-          <p:cNvPr id="16" name="Text 8"/>
+      <p:sp>
+        <p:nvSpPr>
+          <p:cNvPr id="12" name="Text 9"/>
           <p:cNvSpPr txBox="1"/>
           <p:nvPr/>
         </p:nvSpPr>
         <p:spPr>
           <a:xfrm>
-            <a:off x="4663440" y="2148840"/>
-            <a:ext cx="1874520" cy="365760"/>
-          </a:xfrm>
-          <a:prstGeom prst="rect">
-            <a:avLst/>
-          </a:prstGeom>
-          <a:noFill/>
-          <a:ln/>
-        </p:spPr>
-        <p:txBody>
-          <a:bodyPr wrap="square" lIns="0" tIns="0" rIns="0" bIns="0" rtlCol="0" anchor="t"/>
+            <a:off x="685800" y="2596896"/>
+            <a:ext cx="1005840" cy="292608"/>
+          </a:xfrm>
+          <a:prstGeom prst="rect">
+            <a:avLst/>
+          </a:prstGeom>
+          <a:noFill/>
+          <a:ln/>
+        </p:spPr>
+        <p:txBody>
+          <a:bodyPr wrap="square" lIns="0" tIns="0" rIns="0" bIns="0" rtlCol="0" anchor="ctr"/>
           <a:lstStyle/>
           <a:p>
             <a:pPr algn="ctr" indent="0" marL="0">
               <a:lnSpc>
-                <a:spcPts val="2000"/>
-              </a:lnSpc>
-              <a:buNone/>
-            </a:pPr>
-            <a:r>
-              <a:rPr lang="en-US" sz="1600" b="1" dirty="0">
-                <a:solidFill>
-                  <a:schemeClr val="tx2"/>
-                </a:solidFill>
-              </a:rPr>
-              <a:t>五日療程</a:t>
-            </a:r>
-            <a:endParaRPr lang="en-US" sz="1600" dirty="0"/>
-          </a:p>
-        </p:txBody>
-      </p:sp>
-      <p:sp>
-        <p:nvSpPr>
-          <p:cNvPr id="17" name="Text 9"/>
+                <a:spcPts val="1400"/>
+              </a:lnSpc>
+              <a:buNone/>
+            </a:pPr>
+            <a:r>
+              <a:rPr lang="en-US" sz="1100" b="1" dirty="0">
+                <a:solidFill>
+                  <a:schemeClr val="bg1"/>
+                </a:solidFill>
+              </a:rPr>
+              <a:t>音療</a:t>
+            </a:r>
+            <a:endParaRPr lang="en-US" sz="1100" dirty="0"/>
+          </a:p>
+        </p:txBody>
+      </p:sp>
+      <p:sp>
+        <p:nvSpPr>
+          <p:cNvPr id="13" name="Text 10"/>
           <p:cNvSpPr txBox="1"/>
           <p:nvPr/>
         </p:nvSpPr>
         <p:spPr>
           <a:xfrm>
-            <a:off x="4754880" y="2560320"/>
-            <a:ext cx="1691640" cy="777240"/>
-          </a:xfrm>
-          <a:prstGeom prst="rect">
-            <a:avLst/>
-          </a:prstGeom>
-          <a:noFill/>
-          <a:ln/>
-        </p:spPr>
-        <p:txBody>
-          <a:bodyPr wrap="square" lIns="0" tIns="0" rIns="0" bIns="0" rtlCol="0" anchor="t"/>
+            <a:off x="1828800" y="2596896"/>
+            <a:ext cx="2514600" cy="292608"/>
+          </a:xfrm>
+          <a:prstGeom prst="rect">
+            <a:avLst/>
+          </a:prstGeom>
+          <a:noFill/>
+          <a:ln/>
+        </p:spPr>
+        <p:txBody>
+          <a:bodyPr wrap="square" lIns="0" tIns="0" rIns="0" bIns="0" rtlCol="0" anchor="ctr"/>
           <a:lstStyle/>
           <a:p>
             <a:pPr indent="0" marL="0">
               <a:lnSpc>
-                <a:spcPts val="1500"/>
-              </a:lnSpc>
-              <a:buNone/>
-            </a:pPr>
-            <a:r>
-              <a:rPr lang="en-US" sz="1200" dirty="0">
+                <a:spcPts val="1600"/>
+              </a:lnSpc>
+              <a:buNone/>
+            </a:pPr>
+            <a:r>
+              <a:rPr lang="en-US" sz="1300" dirty="0">
                 <a:solidFill>
                   <a:schemeClr val="tx1"/>
                 </a:solidFill>
               </a:rPr>
-              <a:t>評估 → 放鬆 → 調理 → 整合 → 返家</a:t>
-            </a:r>
-            <a:endParaRPr lang="en-US" sz="1200" dirty="0"/>
-          </a:p>
-        </p:txBody>
-      </p:sp>
-      <p:sp>
-        <p:nvSpPr>
-          <p:cNvPr id="18" name="退房後測 circle"/>
+              <a:t>山泉、鳥鳴自然聲音浴</a:t>
+            </a:r>
+            <a:endParaRPr lang="en-US" sz="1300" dirty="0"/>
+          </a:p>
+        </p:txBody>
+      </p:sp>
+      <p:sp>
+        <p:nvSpPr>
+          <p:cNvPr id="14" name="山・山居療癒 tag 3"/>
           <p:cNvSpPr/>
           <p:nvPr/>
         </p:nvSpPr>
         <p:spPr>
           <a:xfrm>
-            <a:off x="7315200" y="1234440"/>
-            <a:ext cx="777240" cy="777240"/>
-          </a:xfrm>
-          <a:prstGeom prst="ellipse">
-            <a:avLst/>
-          </a:prstGeom>
-          <a:solidFill>
-            <a:srgbClr val="C07A4F"/>
-          </a:solidFill>
-          <a:ln w="12700">
-            <a:solidFill>
-              <a:srgbClr val="C07A4F"/>
-            </a:solidFill>
-            <a:prstDash val="solid"/>
-          </a:ln>
-        </p:spPr>
-      </p:sp>
-      <p:pic>
-        <p:nvPicPr>
-          <p:cNvPr id="19" name="退房後測 icon" descr="退房後測">    </p:cNvPr>
-          <p:cNvPicPr>
-            <a:picLocks noChangeAspect="1"/>
-          </p:cNvPicPr>
-          <p:nvPr/>
-        </p:nvPicPr>
-        <p:blipFill>
-          <a:blip r:embed="rId7"/>
-          <a:stretch>
-            <a:fillRect/>
-          </a:stretch>
-        </p:blipFill>
-        <p:spPr>
-          <a:xfrm>
-            <a:off x="7509510" y="1428750"/>
-            <a:ext cx="388620" cy="388620"/>
-          </a:xfrm>
-          <a:prstGeom prst="rect">
-            <a:avLst/>
-          </a:prstGeom>
-        </p:spPr>
-      </p:pic>
-      <p:sp>
-        <p:nvSpPr>
-          <p:cNvPr id="20" name="Text 11"/>
-          <p:cNvSpPr txBox="1"/>
-          <p:nvPr/>
-        </p:nvSpPr>
-        <p:spPr>
-          <a:xfrm>
-            <a:off x="6766560" y="2148840"/>
-            <a:ext cx="1874520" cy="365760"/>
-          </a:xfrm>
-          <a:prstGeom prst="rect">
-            <a:avLst/>
-          </a:prstGeom>
-          <a:noFill/>
-          <a:ln/>
-        </p:spPr>
-        <p:txBody>
-          <a:bodyPr wrap="square" lIns="0" tIns="0" rIns="0" bIns="0" rtlCol="0" anchor="t"/>
-          <a:lstStyle/>
-          <a:p>
-            <a:pPr algn="ctr" indent="0" marL="0">
-              <a:lnSpc>
-                <a:spcPts val="2000"/>
-              </a:lnSpc>
-              <a:buNone/>
-            </a:pPr>
-            <a:r>
-              <a:rPr lang="en-US" sz="1600" b="1" dirty="0">
-                <a:solidFill>
-                  <a:schemeClr val="tx2"/>
-                </a:solidFill>
-              </a:rPr>
-              <a:t>退房後測</a:t>
-            </a:r>
-            <a:endParaRPr lang="en-US" sz="1600" dirty="0"/>
-          </a:p>
-        </p:txBody>
-      </p:sp>
-      <p:sp>
-        <p:nvSpPr>
-          <p:cNvPr id="21" name="Text 12"/>
-          <p:cNvSpPr txBox="1"/>
-          <p:nvPr/>
-        </p:nvSpPr>
-        <p:spPr>
-          <a:xfrm>
-            <a:off x="6858000" y="2560320"/>
-            <a:ext cx="1691640" cy="777240"/>
-          </a:xfrm>
-          <a:prstGeom prst="rect">
-            <a:avLst/>
-          </a:prstGeom>
-          <a:noFill/>
-          <a:ln/>
-        </p:spPr>
-        <p:txBody>
-          <a:bodyPr wrap="square" lIns="0" tIns="0" rIns="0" bIns="0" rtlCol="0" anchor="t"/>
-          <a:lstStyle/>
-          <a:p>
-            <a:pPr indent="0" marL="0">
-              <a:lnSpc>
-                <a:spcPts val="1500"/>
-              </a:lnSpc>
-              <a:buNone/>
-            </a:pPr>
-            <a:r>
-              <a:rPr lang="en-US" sz="1200" dirty="0">
-                <a:solidFill>
-                  <a:schemeClr val="tx1"/>
-                </a:solidFill>
-              </a:rPr>
-              <a:t>退房前再測一次，與前測對照</a:t>
-            </a:r>
-            <a:endParaRPr lang="en-US" sz="1200" dirty="0"/>
-          </a:p>
-        </p:txBody>
-      </p:sp>
-      <p:sp>
-        <p:nvSpPr>
-          <p:cNvPr id="22" name="Report callout"/>
-          <p:cNvSpPr/>
-          <p:nvPr/>
-        </p:nvSpPr>
-        <p:spPr>
-          <a:xfrm>
-            <a:off x="457200" y="3520440"/>
-            <a:ext cx="8229600" cy="914400"/>
+            <a:off x="685800" y="2999232"/>
+            <a:ext cx="1005840" cy="292608"/>
           </a:xfrm>
           <a:prstGeom prst="roundRect">
             <a:avLst>
-              <a:gd name="adj" fmla="val 8000"/>
+              <a:gd name="adj" fmla="val 50000"/>
             </a:avLst>
           </a:prstGeom>
           <a:solidFill>
@@ -3042,14 +2916,14 @@
       </p:sp>
       <p:sp>
         <p:nvSpPr>
-          <p:cNvPr id="23" name="Text 14"/>
+          <p:cNvPr id="15" name="Text 12"/>
           <p:cNvSpPr txBox="1"/>
           <p:nvPr/>
         </p:nvSpPr>
         <p:spPr>
           <a:xfrm>
-            <a:off x="731520" y="3520440"/>
-            <a:ext cx="2377440" cy="914400"/>
+            <a:off x="685800" y="2999232"/>
+            <a:ext cx="1005840" cy="292608"/>
           </a:xfrm>
           <a:prstGeom prst="rect">
             <a:avLst/>
@@ -3061,34 +2935,139 @@
           <a:bodyPr wrap="square" lIns="0" tIns="0" rIns="0" bIns="0" rtlCol="0" anchor="ctr"/>
           <a:lstStyle/>
           <a:p>
+            <a:pPr algn="ctr" indent="0" marL="0">
+              <a:lnSpc>
+                <a:spcPts val="1400"/>
+              </a:lnSpc>
+              <a:buNone/>
+            </a:pPr>
+            <a:r>
+              <a:rPr lang="en-US" sz="1100" b="1" dirty="0">
+                <a:solidFill>
+                  <a:schemeClr val="bg1"/>
+                </a:solidFill>
+              </a:rPr>
+              <a:t>放鬆療癒</a:t>
+            </a:r>
+            <a:endParaRPr lang="en-US" sz="1100" dirty="0"/>
+          </a:p>
+        </p:txBody>
+      </p:sp>
+      <p:sp>
+        <p:nvSpPr>
+          <p:cNvPr id="16" name="Text 13"/>
+          <p:cNvSpPr txBox="1"/>
+          <p:nvPr/>
+        </p:nvSpPr>
+        <p:spPr>
+          <a:xfrm>
+            <a:off x="1828800" y="2999232"/>
+            <a:ext cx="2514600" cy="292608"/>
+          </a:xfrm>
+          <a:prstGeom prst="rect">
+            <a:avLst/>
+          </a:prstGeom>
+          <a:noFill/>
+          <a:ln/>
+        </p:spPr>
+        <p:txBody>
+          <a:bodyPr wrap="square" lIns="0" tIns="0" rIns="0" bIns="0" rtlCol="0" anchor="ctr"/>
+          <a:lstStyle/>
+          <a:p>
             <a:pPr indent="0" marL="0">
               <a:lnSpc>
-                <a:spcPts val="2500"/>
-              </a:lnSpc>
-              <a:buNone/>
-            </a:pPr>
-            <a:r>
-              <a:rPr lang="en-US" sz="2000" b="1" dirty="0">
+                <a:spcPts val="1600"/>
+              </a:lnSpc>
+              <a:buNone/>
+            </a:pPr>
+            <a:r>
+              <a:rPr lang="en-US" sz="1300" dirty="0">
+                <a:solidFill>
+                  <a:schemeClr val="tx1"/>
+                </a:solidFill>
+              </a:rPr>
+              <a:t>山泉溫泡、足浴</a:t>
+            </a:r>
+            <a:endParaRPr lang="en-US" sz="1300" dirty="0"/>
+          </a:p>
+        </p:txBody>
+      </p:sp>
+      <p:sp>
+        <p:nvSpPr>
+          <p:cNvPr id="17" name="山・山居療癒 tag 4"/>
+          <p:cNvSpPr/>
+          <p:nvPr/>
+        </p:nvSpPr>
+        <p:spPr>
+          <a:xfrm>
+            <a:off x="685800" y="3401568"/>
+            <a:ext cx="1005840" cy="292608"/>
+          </a:xfrm>
+          <a:prstGeom prst="roundRect">
+            <a:avLst>
+              <a:gd name="adj" fmla="val 50000"/>
+            </a:avLst>
+          </a:prstGeom>
+          <a:solidFill>
+            <a:srgbClr val="2F4A3A"/>
+          </a:solidFill>
+          <a:ln w="12700">
+            <a:solidFill>
+              <a:srgbClr val="2F4A3A"/>
+            </a:solidFill>
+            <a:prstDash val="solid"/>
+          </a:ln>
+        </p:spPr>
+      </p:sp>
+      <p:sp>
+        <p:nvSpPr>
+          <p:cNvPr id="18" name="Text 15"/>
+          <p:cNvSpPr txBox="1"/>
+          <p:nvPr/>
+        </p:nvSpPr>
+        <p:spPr>
+          <a:xfrm>
+            <a:off x="685800" y="3401568"/>
+            <a:ext cx="1005840" cy="292608"/>
+          </a:xfrm>
+          <a:prstGeom prst="rect">
+            <a:avLst/>
+          </a:prstGeom>
+          <a:noFill/>
+          <a:ln/>
+        </p:spPr>
+        <p:txBody>
+          <a:bodyPr wrap="square" lIns="0" tIns="0" rIns="0" bIns="0" rtlCol="0" anchor="ctr"/>
+          <a:lstStyle/>
+          <a:p>
+            <a:pPr algn="ctr" indent="0" marL="0">
+              <a:lnSpc>
+                <a:spcPts val="1400"/>
+              </a:lnSpc>
+              <a:buNone/>
+            </a:pPr>
+            <a:r>
+              <a:rPr lang="en-US" sz="1100" b="1" dirty="0">
                 <a:solidFill>
                   <a:schemeClr val="bg1"/>
                 </a:solidFill>
               </a:rPr>
-              <a:t>「五日健康報告」</a:t>
-            </a:r>
-            <a:endParaRPr lang="en-US" sz="2000" dirty="0"/>
-          </a:p>
-        </p:txBody>
-      </p:sp>
-      <p:sp>
-        <p:nvSpPr>
-          <p:cNvPr id="24" name="Text 15"/>
+              <a:t>食療</a:t>
+            </a:r>
+            <a:endParaRPr lang="en-US" sz="1100" dirty="0"/>
+          </a:p>
+        </p:txBody>
+      </p:sp>
+      <p:sp>
+        <p:nvSpPr>
+          <p:cNvPr id="19" name="Text 16"/>
           <p:cNvSpPr txBox="1"/>
           <p:nvPr/>
         </p:nvSpPr>
         <p:spPr>
           <a:xfrm>
-            <a:off x="3200400" y="3520440"/>
-            <a:ext cx="5303520" cy="914400"/>
+            <a:off x="1828800" y="3401568"/>
+            <a:ext cx="2514600" cy="292608"/>
           </a:xfrm>
           <a:prstGeom prst="rect">
             <a:avLst/>
@@ -3102,19 +3081,620 @@
           <a:p>
             <a:pPr indent="0" marL="0">
               <a:lnSpc>
-                <a:spcPts val="1800"/>
-              </a:lnSpc>
-              <a:buNone/>
-            </a:pPr>
-            <a:r>
-              <a:rPr lang="en-US" sz="1400" dirty="0">
-                <a:solidFill>
-                  <a:schemeClr val="accent4"/>
-                </a:solidFill>
-              </a:rPr>
-              <a:t>前後測對照，讓學員看見五天的變化——是口碑與回購的關鍵。</a:t>
-            </a:r>
-            <a:endParaRPr lang="en-US" sz="1400" dirty="0"/>
+                <a:spcPts val="1600"/>
+              </a:lnSpc>
+              <a:buNone/>
+            </a:pPr>
+            <a:r>
+              <a:rPr lang="en-US" sz="1300" dirty="0">
+                <a:solidFill>
+                  <a:schemeClr val="tx1"/>
+                </a:solidFill>
+              </a:rPr>
+              <a:t>山野時令食材入藥膳</a:t>
+            </a:r>
+            <a:endParaRPr lang="en-US" sz="1300" dirty="0"/>
+          </a:p>
+        </p:txBody>
+      </p:sp>
+      <p:sp>
+        <p:nvSpPr>
+          <p:cNvPr id="20" name="水・海居／水岸療癒"/>
+          <p:cNvSpPr/>
+          <p:nvPr/>
+        </p:nvSpPr>
+        <p:spPr>
+          <a:xfrm>
+            <a:off x="4663440" y="1325880"/>
+            <a:ext cx="4023360" cy="2514600"/>
+          </a:xfrm>
+          <a:prstGeom prst="roundRect">
+            <a:avLst>
+              <a:gd name="adj" fmla="val 2909"/>
+            </a:avLst>
+          </a:prstGeom>
+          <a:solidFill>
+            <a:srgbClr val="EEF3EC"/>
+          </a:solidFill>
+          <a:ln w="12700">
+            <a:solidFill>
+              <a:srgbClr val="EEF3EC"/>
+            </a:solidFill>
+            <a:prstDash val="solid"/>
+          </a:ln>
+        </p:spPr>
+      </p:sp>
+      <p:sp>
+        <p:nvSpPr>
+          <p:cNvPr id="21" name="水・海居／水岸療癒 circle"/>
+          <p:cNvSpPr/>
+          <p:nvPr/>
+        </p:nvSpPr>
+        <p:spPr>
+          <a:xfrm>
+            <a:off x="4892040" y="1463040"/>
+            <a:ext cx="548640" cy="548640"/>
+          </a:xfrm>
+          <a:prstGeom prst="ellipse">
+            <a:avLst/>
+          </a:prstGeom>
+          <a:solidFill>
+            <a:srgbClr val="3E6B7A"/>
+          </a:solidFill>
+          <a:ln w="12700">
+            <a:solidFill>
+              <a:srgbClr val="3E6B7A"/>
+            </a:solidFill>
+            <a:prstDash val="solid"/>
+          </a:ln>
+        </p:spPr>
+      </p:sp>
+      <p:pic>
+        <p:nvPicPr>
+          <p:cNvPr id="22" name="水・海居／水岸療癒 icon" descr="水・海居／水岸療癒">    </p:cNvPr>
+          <p:cNvPicPr>
+            <a:picLocks noChangeAspect="1"/>
+          </p:cNvPicPr>
+          <p:nvPr/>
+        </p:nvPicPr>
+        <p:blipFill>
+          <a:blip r:embed="rId2"/>
+          <a:stretch>
+            <a:fillRect/>
+          </a:stretch>
+        </p:blipFill>
+        <p:spPr>
+          <a:xfrm>
+            <a:off x="5029200" y="1600200"/>
+            <a:ext cx="274320" cy="274320"/>
+          </a:xfrm>
+          <a:prstGeom prst="rect">
+            <a:avLst/>
+          </a:prstGeom>
+        </p:spPr>
+      </p:pic>
+      <p:sp>
+        <p:nvSpPr>
+          <p:cNvPr id="23" name="Text 19"/>
+          <p:cNvSpPr txBox="1"/>
+          <p:nvPr/>
+        </p:nvSpPr>
+        <p:spPr>
+          <a:xfrm>
+            <a:off x="5577840" y="1572768"/>
+            <a:ext cx="2926080" cy="365760"/>
+          </a:xfrm>
+          <a:prstGeom prst="rect">
+            <a:avLst/>
+          </a:prstGeom>
+          <a:noFill/>
+          <a:ln/>
+        </p:spPr>
+        <p:txBody>
+          <a:bodyPr wrap="square" lIns="0" tIns="0" rIns="0" bIns="0" rtlCol="0" anchor="t"/>
+          <a:lstStyle/>
+          <a:p>
+            <a:pPr indent="0" marL="0">
+              <a:lnSpc>
+                <a:spcPts val="2100"/>
+              </a:lnSpc>
+              <a:buNone/>
+            </a:pPr>
+            <a:r>
+              <a:rPr lang="en-US" sz="1700" b="1" dirty="0">
+                <a:solidFill>
+                  <a:schemeClr val="tx2"/>
+                </a:solidFill>
+              </a:rPr>
+              <a:t>水・海居／水岸療癒</a:t>
+            </a:r>
+            <a:endParaRPr lang="en-US" sz="1700" dirty="0"/>
+          </a:p>
+        </p:txBody>
+      </p:sp>
+      <p:sp>
+        <p:nvSpPr>
+          <p:cNvPr id="24" name="水・海居／水岸療癒 tag 1"/>
+          <p:cNvSpPr/>
+          <p:nvPr/>
+        </p:nvSpPr>
+        <p:spPr>
+          <a:xfrm>
+            <a:off x="4892040" y="2194560"/>
+            <a:ext cx="1005840" cy="292608"/>
+          </a:xfrm>
+          <a:prstGeom prst="roundRect">
+            <a:avLst>
+              <a:gd name="adj" fmla="val 50000"/>
+            </a:avLst>
+          </a:prstGeom>
+          <a:solidFill>
+            <a:srgbClr val="3E6B7A"/>
+          </a:solidFill>
+          <a:ln w="12700">
+            <a:solidFill>
+              <a:srgbClr val="3E6B7A"/>
+            </a:solidFill>
+            <a:prstDash val="solid"/>
+          </a:ln>
+        </p:spPr>
+      </p:sp>
+      <p:sp>
+        <p:nvSpPr>
+          <p:cNvPr id="25" name="Text 21"/>
+          <p:cNvSpPr txBox="1"/>
+          <p:nvPr/>
+        </p:nvSpPr>
+        <p:spPr>
+          <a:xfrm>
+            <a:off x="4892040" y="2194560"/>
+            <a:ext cx="1005840" cy="292608"/>
+          </a:xfrm>
+          <a:prstGeom prst="rect">
+            <a:avLst/>
+          </a:prstGeom>
+          <a:noFill/>
+          <a:ln/>
+        </p:spPr>
+        <p:txBody>
+          <a:bodyPr wrap="square" lIns="0" tIns="0" rIns="0" bIns="0" rtlCol="0" anchor="ctr"/>
+          <a:lstStyle/>
+          <a:p>
+            <a:pPr algn="ctr" indent="0" marL="0">
+              <a:lnSpc>
+                <a:spcPts val="1400"/>
+              </a:lnSpc>
+              <a:buNone/>
+            </a:pPr>
+            <a:r>
+              <a:rPr lang="en-US" sz="1100" b="1" dirty="0">
+                <a:solidFill>
+                  <a:schemeClr val="bg1"/>
+                </a:solidFill>
+              </a:rPr>
+              <a:t>自然療癒</a:t>
+            </a:r>
+            <a:endParaRPr lang="en-US" sz="1100" dirty="0"/>
+          </a:p>
+        </p:txBody>
+      </p:sp>
+      <p:sp>
+        <p:nvSpPr>
+          <p:cNvPr id="26" name="Text 22"/>
+          <p:cNvSpPr txBox="1"/>
+          <p:nvPr/>
+        </p:nvSpPr>
+        <p:spPr>
+          <a:xfrm>
+            <a:off x="6035040" y="2194560"/>
+            <a:ext cx="2514600" cy="292608"/>
+          </a:xfrm>
+          <a:prstGeom prst="rect">
+            <a:avLst/>
+          </a:prstGeom>
+          <a:noFill/>
+          <a:ln/>
+        </p:spPr>
+        <p:txBody>
+          <a:bodyPr wrap="square" lIns="0" tIns="0" rIns="0" bIns="0" rtlCol="0" anchor="ctr"/>
+          <a:lstStyle/>
+          <a:p>
+            <a:pPr indent="0" marL="0">
+              <a:lnSpc>
+                <a:spcPts val="1600"/>
+              </a:lnSpc>
+              <a:buNone/>
+            </a:pPr>
+            <a:r>
+              <a:rPr lang="en-US" sz="1300" dirty="0">
+                <a:solidFill>
+                  <a:schemeClr val="tx1"/>
+                </a:solidFill>
+              </a:rPr>
+              <a:t>海邊／湖畔散步、呼吸練習</a:t>
+            </a:r>
+            <a:endParaRPr lang="en-US" sz="1300" dirty="0"/>
+          </a:p>
+        </p:txBody>
+      </p:sp>
+      <p:sp>
+        <p:nvSpPr>
+          <p:cNvPr id="27" name="水・海居／水岸療癒 tag 2"/>
+          <p:cNvSpPr/>
+          <p:nvPr/>
+        </p:nvSpPr>
+        <p:spPr>
+          <a:xfrm>
+            <a:off x="4892040" y="2596896"/>
+            <a:ext cx="1005840" cy="292608"/>
+          </a:xfrm>
+          <a:prstGeom prst="roundRect">
+            <a:avLst>
+              <a:gd name="adj" fmla="val 50000"/>
+            </a:avLst>
+          </a:prstGeom>
+          <a:solidFill>
+            <a:srgbClr val="3E6B7A"/>
+          </a:solidFill>
+          <a:ln w="12700">
+            <a:solidFill>
+              <a:srgbClr val="3E6B7A"/>
+            </a:solidFill>
+            <a:prstDash val="solid"/>
+          </a:ln>
+        </p:spPr>
+      </p:sp>
+      <p:sp>
+        <p:nvSpPr>
+          <p:cNvPr id="28" name="Text 24"/>
+          <p:cNvSpPr txBox="1"/>
+          <p:nvPr/>
+        </p:nvSpPr>
+        <p:spPr>
+          <a:xfrm>
+            <a:off x="4892040" y="2596896"/>
+            <a:ext cx="1005840" cy="292608"/>
+          </a:xfrm>
+          <a:prstGeom prst="rect">
+            <a:avLst/>
+          </a:prstGeom>
+          <a:noFill/>
+          <a:ln/>
+        </p:spPr>
+        <p:txBody>
+          <a:bodyPr wrap="square" lIns="0" tIns="0" rIns="0" bIns="0" rtlCol="0" anchor="ctr"/>
+          <a:lstStyle/>
+          <a:p>
+            <a:pPr algn="ctr" indent="0" marL="0">
+              <a:lnSpc>
+                <a:spcPts val="1400"/>
+              </a:lnSpc>
+              <a:buNone/>
+            </a:pPr>
+            <a:r>
+              <a:rPr lang="en-US" sz="1100" b="1" dirty="0">
+                <a:solidFill>
+                  <a:schemeClr val="bg1"/>
+                </a:solidFill>
+              </a:rPr>
+              <a:t>音療</a:t>
+            </a:r>
+            <a:endParaRPr lang="en-US" sz="1100" dirty="0"/>
+          </a:p>
+        </p:txBody>
+      </p:sp>
+      <p:sp>
+        <p:nvSpPr>
+          <p:cNvPr id="29" name="Text 25"/>
+          <p:cNvSpPr txBox="1"/>
+          <p:nvPr/>
+        </p:nvSpPr>
+        <p:spPr>
+          <a:xfrm>
+            <a:off x="6035040" y="2596896"/>
+            <a:ext cx="2514600" cy="292608"/>
+          </a:xfrm>
+          <a:prstGeom prst="rect">
+            <a:avLst/>
+          </a:prstGeom>
+          <a:noFill/>
+          <a:ln/>
+        </p:spPr>
+        <p:txBody>
+          <a:bodyPr wrap="square" lIns="0" tIns="0" rIns="0" bIns="0" rtlCol="0" anchor="ctr"/>
+          <a:lstStyle/>
+          <a:p>
+            <a:pPr indent="0" marL="0">
+              <a:lnSpc>
+                <a:spcPts val="1600"/>
+              </a:lnSpc>
+              <a:buNone/>
+            </a:pPr>
+            <a:r>
+              <a:rPr lang="en-US" sz="1300" dirty="0">
+                <a:solidFill>
+                  <a:schemeClr val="tx1"/>
+                </a:solidFill>
+              </a:rPr>
+              <a:t>海浪、流水聲音浴</a:t>
+            </a:r>
+            <a:endParaRPr lang="en-US" sz="1300" dirty="0"/>
+          </a:p>
+        </p:txBody>
+      </p:sp>
+      <p:sp>
+        <p:nvSpPr>
+          <p:cNvPr id="30" name="水・海居／水岸療癒 tag 3"/>
+          <p:cNvSpPr/>
+          <p:nvPr/>
+        </p:nvSpPr>
+        <p:spPr>
+          <a:xfrm>
+            <a:off x="4892040" y="2999232"/>
+            <a:ext cx="1005840" cy="292608"/>
+          </a:xfrm>
+          <a:prstGeom prst="roundRect">
+            <a:avLst>
+              <a:gd name="adj" fmla="val 50000"/>
+            </a:avLst>
+          </a:prstGeom>
+          <a:solidFill>
+            <a:srgbClr val="3E6B7A"/>
+          </a:solidFill>
+          <a:ln w="12700">
+            <a:solidFill>
+              <a:srgbClr val="3E6B7A"/>
+            </a:solidFill>
+            <a:prstDash val="solid"/>
+          </a:ln>
+        </p:spPr>
+      </p:sp>
+      <p:sp>
+        <p:nvSpPr>
+          <p:cNvPr id="31" name="Text 27"/>
+          <p:cNvSpPr txBox="1"/>
+          <p:nvPr/>
+        </p:nvSpPr>
+        <p:spPr>
+          <a:xfrm>
+            <a:off x="4892040" y="2999232"/>
+            <a:ext cx="1005840" cy="292608"/>
+          </a:xfrm>
+          <a:prstGeom prst="rect">
+            <a:avLst/>
+          </a:prstGeom>
+          <a:noFill/>
+          <a:ln/>
+        </p:spPr>
+        <p:txBody>
+          <a:bodyPr wrap="square" lIns="0" tIns="0" rIns="0" bIns="0" rtlCol="0" anchor="ctr"/>
+          <a:lstStyle/>
+          <a:p>
+            <a:pPr algn="ctr" indent="0" marL="0">
+              <a:lnSpc>
+                <a:spcPts val="1400"/>
+              </a:lnSpc>
+              <a:buNone/>
+            </a:pPr>
+            <a:r>
+              <a:rPr lang="en-US" sz="1100" b="1" dirty="0">
+                <a:solidFill>
+                  <a:schemeClr val="bg1"/>
+                </a:solidFill>
+              </a:rPr>
+              <a:t>冥想</a:t>
+            </a:r>
+            <a:endParaRPr lang="en-US" sz="1100" dirty="0"/>
+          </a:p>
+        </p:txBody>
+      </p:sp>
+      <p:sp>
+        <p:nvSpPr>
+          <p:cNvPr id="32" name="Text 28"/>
+          <p:cNvSpPr txBox="1"/>
+          <p:nvPr/>
+        </p:nvSpPr>
+        <p:spPr>
+          <a:xfrm>
+            <a:off x="6035040" y="2999232"/>
+            <a:ext cx="2514600" cy="292608"/>
+          </a:xfrm>
+          <a:prstGeom prst="rect">
+            <a:avLst/>
+          </a:prstGeom>
+          <a:noFill/>
+          <a:ln/>
+        </p:spPr>
+        <p:txBody>
+          <a:bodyPr wrap="square" lIns="0" tIns="0" rIns="0" bIns="0" rtlCol="0" anchor="ctr"/>
+          <a:lstStyle/>
+          <a:p>
+            <a:pPr indent="0" marL="0">
+              <a:lnSpc>
+                <a:spcPts val="1600"/>
+              </a:lnSpc>
+              <a:buNone/>
+            </a:pPr>
+            <a:r>
+              <a:rPr lang="en-US" sz="1300" dirty="0">
+                <a:solidFill>
+                  <a:schemeClr val="tx1"/>
+                </a:solidFill>
+              </a:rPr>
+              <a:t>水岸日出正念冥想</a:t>
+            </a:r>
+            <a:endParaRPr lang="en-US" sz="1300" dirty="0"/>
+          </a:p>
+        </p:txBody>
+      </p:sp>
+      <p:sp>
+        <p:nvSpPr>
+          <p:cNvPr id="33" name="水・海居／水岸療癒 tag 4"/>
+          <p:cNvSpPr/>
+          <p:nvPr/>
+        </p:nvSpPr>
+        <p:spPr>
+          <a:xfrm>
+            <a:off x="4892040" y="3401568"/>
+            <a:ext cx="1005840" cy="292608"/>
+          </a:xfrm>
+          <a:prstGeom prst="roundRect">
+            <a:avLst>
+              <a:gd name="adj" fmla="val 50000"/>
+            </a:avLst>
+          </a:prstGeom>
+          <a:solidFill>
+            <a:srgbClr val="3E6B7A"/>
+          </a:solidFill>
+          <a:ln w="12700">
+            <a:solidFill>
+              <a:srgbClr val="3E6B7A"/>
+            </a:solidFill>
+            <a:prstDash val="solid"/>
+          </a:ln>
+        </p:spPr>
+      </p:sp>
+      <p:sp>
+        <p:nvSpPr>
+          <p:cNvPr id="34" name="Text 30"/>
+          <p:cNvSpPr txBox="1"/>
+          <p:nvPr/>
+        </p:nvSpPr>
+        <p:spPr>
+          <a:xfrm>
+            <a:off x="4892040" y="3401568"/>
+            <a:ext cx="1005840" cy="292608"/>
+          </a:xfrm>
+          <a:prstGeom prst="rect">
+            <a:avLst/>
+          </a:prstGeom>
+          <a:noFill/>
+          <a:ln/>
+        </p:spPr>
+        <p:txBody>
+          <a:bodyPr wrap="square" lIns="0" tIns="0" rIns="0" bIns="0" rtlCol="0" anchor="ctr"/>
+          <a:lstStyle/>
+          <a:p>
+            <a:pPr algn="ctr" indent="0" marL="0">
+              <a:lnSpc>
+                <a:spcPts val="1400"/>
+              </a:lnSpc>
+              <a:buNone/>
+            </a:pPr>
+            <a:r>
+              <a:rPr lang="en-US" sz="1100" b="1" dirty="0">
+                <a:solidFill>
+                  <a:schemeClr val="bg1"/>
+                </a:solidFill>
+              </a:rPr>
+              <a:t>睡眠療癒</a:t>
+            </a:r>
+            <a:endParaRPr lang="en-US" sz="1100" dirty="0"/>
+          </a:p>
+        </p:txBody>
+      </p:sp>
+      <p:sp>
+        <p:nvSpPr>
+          <p:cNvPr id="35" name="Text 31"/>
+          <p:cNvSpPr txBox="1"/>
+          <p:nvPr/>
+        </p:nvSpPr>
+        <p:spPr>
+          <a:xfrm>
+            <a:off x="6035040" y="3401568"/>
+            <a:ext cx="2514600" cy="292608"/>
+          </a:xfrm>
+          <a:prstGeom prst="rect">
+            <a:avLst/>
+          </a:prstGeom>
+          <a:noFill/>
+          <a:ln/>
+        </p:spPr>
+        <p:txBody>
+          <a:bodyPr wrap="square" lIns="0" tIns="0" rIns="0" bIns="0" rtlCol="0" anchor="ctr"/>
+          <a:lstStyle/>
+          <a:p>
+            <a:pPr indent="0" marL="0">
+              <a:lnSpc>
+                <a:spcPts val="1600"/>
+              </a:lnSpc>
+              <a:buNone/>
+            </a:pPr>
+            <a:r>
+              <a:rPr lang="en-US" sz="1300" dirty="0">
+                <a:solidFill>
+                  <a:schemeClr val="tx1"/>
+                </a:solidFill>
+              </a:rPr>
+              <a:t>水聲伴眠、靜夜水景</a:t>
+            </a:r>
+            <a:endParaRPr lang="en-US" sz="1300" dirty="0"/>
+          </a:p>
+        </p:txBody>
+      </p:sp>
+      <p:sp>
+        <p:nvSpPr>
+          <p:cNvPr id="36" name="Synergy callout"/>
+          <p:cNvSpPr/>
+          <p:nvPr/>
+        </p:nvSpPr>
+        <p:spPr>
+          <a:xfrm>
+            <a:off x="457200" y="3977640"/>
+            <a:ext cx="8229600" cy="594360"/>
+          </a:xfrm>
+          <a:prstGeom prst="roundRect">
+            <a:avLst>
+              <a:gd name="adj" fmla="val 12308"/>
+            </a:avLst>
+          </a:prstGeom>
+          <a:solidFill>
+            <a:srgbClr val="2F4A3A"/>
+          </a:solidFill>
+          <a:ln w="12700">
+            <a:solidFill>
+              <a:srgbClr val="2F4A3A"/>
+            </a:solidFill>
+            <a:prstDash val="solid"/>
+          </a:ln>
+        </p:spPr>
+      </p:sp>
+      <p:sp>
+        <p:nvSpPr>
+          <p:cNvPr id="37" name="Text 33"/>
+          <p:cNvSpPr txBox="1"/>
+          <p:nvPr/>
+        </p:nvSpPr>
+        <p:spPr>
+          <a:xfrm>
+            <a:off x="685800" y="3977640"/>
+            <a:ext cx="7772400" cy="594360"/>
+          </a:xfrm>
+          <a:prstGeom prst="rect">
+            <a:avLst/>
+          </a:prstGeom>
+          <a:noFill/>
+          <a:ln/>
+        </p:spPr>
+        <p:txBody>
+          <a:bodyPr wrap="square" lIns="0" tIns="0" rIns="0" bIns="0" rtlCol="0" anchor="ctr"/>
+          <a:lstStyle/>
+          <a:p>
+            <a:pPr indent="0" marL="0">
+              <a:lnSpc>
+                <a:spcPts val="1600"/>
+              </a:lnSpc>
+              <a:buNone/>
+            </a:pPr>
+            <a:r>
+              <a:rPr lang="en-US" sz="1300" b="1" dirty="0">
+                <a:solidFill>
+                  <a:schemeClr val="bg1"/>
+                </a:solidFill>
+              </a:rPr>
+              <a:t>同一套十療，依飯店地景切換「山居版」或「水居版」——酒店的山水資源成為療程的一部分，也利於多酒店複製</a:t>
+            </a:r>
+            <a:endParaRPr lang="en-US" sz="1300" dirty="0"/>
           </a:p>
         </p:txBody>
       </p:sp>
@@ -3223,6 +3803,802 @@
                   <a:schemeClr val="tx2"/>
                 </a:solidFill>
               </a:rPr>
+              <a:t>個人化方式：前測 → 後測 → 五日健康報告</a:t>
+            </a:r>
+            <a:endParaRPr lang="en-US" sz="2800" dirty="0"/>
+          </a:p>
+        </p:txBody>
+      </p:sp>
+      <p:sp>
+        <p:nvSpPr>
+          <p:cNvPr id="3" name="入住前測 circle"/>
+          <p:cNvSpPr/>
+          <p:nvPr/>
+        </p:nvSpPr>
+        <p:spPr>
+          <a:xfrm>
+            <a:off x="1005840" y="1234440"/>
+            <a:ext cx="777240" cy="777240"/>
+          </a:xfrm>
+          <a:prstGeom prst="ellipse">
+            <a:avLst/>
+          </a:prstGeom>
+          <a:solidFill>
+            <a:srgbClr val="2F4A3A"/>
+          </a:solidFill>
+          <a:ln w="12700">
+            <a:solidFill>
+              <a:srgbClr val="2F4A3A"/>
+            </a:solidFill>
+            <a:prstDash val="solid"/>
+          </a:ln>
+        </p:spPr>
+      </p:sp>
+      <p:pic>
+        <p:nvPicPr>
+          <p:cNvPr id="4" name="入住前測 icon" descr="入住前測">    </p:cNvPr>
+          <p:cNvPicPr>
+            <a:picLocks noChangeAspect="1"/>
+          </p:cNvPicPr>
+          <p:nvPr/>
+        </p:nvPicPr>
+        <p:blipFill>
+          <a:blip r:embed="rId1"/>
+          <a:stretch>
+            <a:fillRect/>
+          </a:stretch>
+        </p:blipFill>
+        <p:spPr>
+          <a:xfrm>
+            <a:off x="1200150" y="1428750"/>
+            <a:ext cx="388620" cy="388620"/>
+          </a:xfrm>
+          <a:prstGeom prst="rect">
+            <a:avLst/>
+          </a:prstGeom>
+        </p:spPr>
+      </p:pic>
+      <p:pic>
+        <p:nvPicPr>
+          <p:cNvPr id="5" name="Arrow 1" descr="next">    </p:cNvPr>
+          <p:cNvPicPr>
+            <a:picLocks noChangeAspect="1"/>
+          </p:cNvPicPr>
+          <p:nvPr/>
+        </p:nvPicPr>
+        <p:blipFill>
+          <a:blip r:embed="rId2"/>
+          <a:stretch>
+            <a:fillRect/>
+          </a:stretch>
+        </p:blipFill>
+        <p:spPr>
+          <a:xfrm>
+            <a:off x="2148840" y="1463040"/>
+            <a:ext cx="320040" cy="320040"/>
+          </a:xfrm>
+          <a:prstGeom prst="rect">
+            <a:avLst/>
+          </a:prstGeom>
+        </p:spPr>
+      </p:pic>
+      <p:sp>
+        <p:nvSpPr>
+          <p:cNvPr id="6" name="Text 2"/>
+          <p:cNvSpPr txBox="1"/>
+          <p:nvPr/>
+        </p:nvSpPr>
+        <p:spPr>
+          <a:xfrm>
+            <a:off x="457200" y="2148840"/>
+            <a:ext cx="1874520" cy="365760"/>
+          </a:xfrm>
+          <a:prstGeom prst="rect">
+            <a:avLst/>
+          </a:prstGeom>
+          <a:noFill/>
+          <a:ln/>
+        </p:spPr>
+        <p:txBody>
+          <a:bodyPr wrap="square" lIns="0" tIns="0" rIns="0" bIns="0" rtlCol="0" anchor="t"/>
+          <a:lstStyle/>
+          <a:p>
+            <a:pPr algn="ctr" indent="0" marL="0">
+              <a:lnSpc>
+                <a:spcPts val="2000"/>
+              </a:lnSpc>
+              <a:buNone/>
+            </a:pPr>
+            <a:r>
+              <a:rPr lang="en-US" sz="1600" b="1" dirty="0">
+                <a:solidFill>
+                  <a:schemeClr val="tx2"/>
+                </a:solidFill>
+              </a:rPr>
+              <a:t>入住前測</a:t>
+            </a:r>
+            <a:endParaRPr lang="en-US" sz="1600" dirty="0"/>
+          </a:p>
+        </p:txBody>
+      </p:sp>
+      <p:sp>
+        <p:nvSpPr>
+          <p:cNvPr id="7" name="Text 3"/>
+          <p:cNvSpPr txBox="1"/>
+          <p:nvPr/>
+        </p:nvSpPr>
+        <p:spPr>
+          <a:xfrm>
+            <a:off x="548640" y="2560320"/>
+            <a:ext cx="1691640" cy="777240"/>
+          </a:xfrm>
+          <a:prstGeom prst="rect">
+            <a:avLst/>
+          </a:prstGeom>
+          <a:noFill/>
+          <a:ln/>
+        </p:spPr>
+        <p:txBody>
+          <a:bodyPr wrap="square" lIns="0" tIns="0" rIns="0" bIns="0" rtlCol="0" anchor="t"/>
+          <a:lstStyle/>
+          <a:p>
+            <a:pPr indent="0" marL="0">
+              <a:lnSpc>
+                <a:spcPts val="1500"/>
+              </a:lnSpc>
+              <a:buNone/>
+            </a:pPr>
+            <a:r>
+              <a:rPr lang="en-US" sz="1200" dirty="0">
+                <a:solidFill>
+                  <a:schemeClr val="tx1"/>
+                </a:solidFill>
+              </a:rPr>
+              <a:t>血壓、血糖、體組成、睡眠問卷、九大體質判定</a:t>
+            </a:r>
+            <a:endParaRPr lang="en-US" sz="1200" dirty="0"/>
+          </a:p>
+        </p:txBody>
+      </p:sp>
+      <p:sp>
+        <p:nvSpPr>
+          <p:cNvPr id="8" name="配對組合 circle"/>
+          <p:cNvSpPr/>
+          <p:nvPr/>
+        </p:nvSpPr>
+        <p:spPr>
+          <a:xfrm>
+            <a:off x="3108960" y="1234440"/>
+            <a:ext cx="777240" cy="777240"/>
+          </a:xfrm>
+          <a:prstGeom prst="ellipse">
+            <a:avLst/>
+          </a:prstGeom>
+          <a:solidFill>
+            <a:srgbClr val="2F4A3A"/>
+          </a:solidFill>
+          <a:ln w="12700">
+            <a:solidFill>
+              <a:srgbClr val="2F4A3A"/>
+            </a:solidFill>
+            <a:prstDash val="solid"/>
+          </a:ln>
+        </p:spPr>
+      </p:sp>
+      <p:pic>
+        <p:nvPicPr>
+          <p:cNvPr id="9" name="配對組合 icon" descr="配對組合">    </p:cNvPr>
+          <p:cNvPicPr>
+            <a:picLocks noChangeAspect="1"/>
+          </p:cNvPicPr>
+          <p:nvPr/>
+        </p:nvPicPr>
+        <p:blipFill>
+          <a:blip r:embed="rId3"/>
+          <a:stretch>
+            <a:fillRect/>
+          </a:stretch>
+        </p:blipFill>
+        <p:spPr>
+          <a:xfrm>
+            <a:off x="3303270" y="1428750"/>
+            <a:ext cx="388620" cy="388620"/>
+          </a:xfrm>
+          <a:prstGeom prst="rect">
+            <a:avLst/>
+          </a:prstGeom>
+        </p:spPr>
+      </p:pic>
+      <p:pic>
+        <p:nvPicPr>
+          <p:cNvPr id="10" name="Arrow 2" descr="next">    </p:cNvPr>
+          <p:cNvPicPr>
+            <a:picLocks noChangeAspect="1"/>
+          </p:cNvPicPr>
+          <p:nvPr/>
+        </p:nvPicPr>
+        <p:blipFill>
+          <a:blip r:embed="rId4"/>
+          <a:stretch>
+            <a:fillRect/>
+          </a:stretch>
+        </p:blipFill>
+        <p:spPr>
+          <a:xfrm>
+            <a:off x="4251960" y="1463040"/>
+            <a:ext cx="320040" cy="320040"/>
+          </a:xfrm>
+          <a:prstGeom prst="rect">
+            <a:avLst/>
+          </a:prstGeom>
+        </p:spPr>
+      </p:pic>
+      <p:sp>
+        <p:nvSpPr>
+          <p:cNvPr id="11" name="Text 5"/>
+          <p:cNvSpPr txBox="1"/>
+          <p:nvPr/>
+        </p:nvSpPr>
+        <p:spPr>
+          <a:xfrm>
+            <a:off x="2560320" y="2148840"/>
+            <a:ext cx="1874520" cy="365760"/>
+          </a:xfrm>
+          <a:prstGeom prst="rect">
+            <a:avLst/>
+          </a:prstGeom>
+          <a:noFill/>
+          <a:ln/>
+        </p:spPr>
+        <p:txBody>
+          <a:bodyPr wrap="square" lIns="0" tIns="0" rIns="0" bIns="0" rtlCol="0" anchor="t"/>
+          <a:lstStyle/>
+          <a:p>
+            <a:pPr algn="ctr" indent="0" marL="0">
+              <a:lnSpc>
+                <a:spcPts val="2000"/>
+              </a:lnSpc>
+              <a:buNone/>
+            </a:pPr>
+            <a:r>
+              <a:rPr lang="en-US" sz="1600" b="1" dirty="0">
+                <a:solidFill>
+                  <a:schemeClr val="tx2"/>
+                </a:solidFill>
+              </a:rPr>
+              <a:t>配對組合</a:t>
+            </a:r>
+            <a:endParaRPr lang="en-US" sz="1600" dirty="0"/>
+          </a:p>
+        </p:txBody>
+      </p:sp>
+      <p:sp>
+        <p:nvSpPr>
+          <p:cNvPr id="12" name="Text 6"/>
+          <p:cNvSpPr txBox="1"/>
+          <p:nvPr/>
+        </p:nvSpPr>
+        <p:spPr>
+          <a:xfrm>
+            <a:off x="2651760" y="2560320"/>
+            <a:ext cx="1691640" cy="777240"/>
+          </a:xfrm>
+          <a:prstGeom prst="rect">
+            <a:avLst/>
+          </a:prstGeom>
+          <a:noFill/>
+          <a:ln/>
+        </p:spPr>
+        <p:txBody>
+          <a:bodyPr wrap="square" lIns="0" tIns="0" rIns="0" bIns="0" rtlCol="0" anchor="t"/>
+          <a:lstStyle/>
+          <a:p>
+            <a:pPr indent="0" marL="0">
+              <a:lnSpc>
+                <a:spcPts val="1500"/>
+              </a:lnSpc>
+              <a:buNone/>
+            </a:pPr>
+            <a:r>
+              <a:rPr lang="en-US" sz="1200" dirty="0">
+                <a:solidFill>
+                  <a:schemeClr val="tx1"/>
+                </a:solidFill>
+              </a:rPr>
+              <a:t>依評估結果，從十大模組配對個人化療程</a:t>
+            </a:r>
+            <a:endParaRPr lang="en-US" sz="1200" dirty="0"/>
+          </a:p>
+        </p:txBody>
+      </p:sp>
+      <p:sp>
+        <p:nvSpPr>
+          <p:cNvPr id="13" name="五日療程 circle"/>
+          <p:cNvSpPr/>
+          <p:nvPr/>
+        </p:nvSpPr>
+        <p:spPr>
+          <a:xfrm>
+            <a:off x="5212080" y="1234440"/>
+            <a:ext cx="777240" cy="777240"/>
+          </a:xfrm>
+          <a:prstGeom prst="ellipse">
+            <a:avLst/>
+          </a:prstGeom>
+          <a:solidFill>
+            <a:srgbClr val="2F4A3A"/>
+          </a:solidFill>
+          <a:ln w="12700">
+            <a:solidFill>
+              <a:srgbClr val="2F4A3A"/>
+            </a:solidFill>
+            <a:prstDash val="solid"/>
+          </a:ln>
+        </p:spPr>
+      </p:sp>
+      <p:pic>
+        <p:nvPicPr>
+          <p:cNvPr id="14" name="五日療程 icon" descr="五日療程">    </p:cNvPr>
+          <p:cNvPicPr>
+            <a:picLocks noChangeAspect="1"/>
+          </p:cNvPicPr>
+          <p:nvPr/>
+        </p:nvPicPr>
+        <p:blipFill>
+          <a:blip r:embed="rId5"/>
+          <a:stretch>
+            <a:fillRect/>
+          </a:stretch>
+        </p:blipFill>
+        <p:spPr>
+          <a:xfrm>
+            <a:off x="5406390" y="1428750"/>
+            <a:ext cx="388620" cy="388620"/>
+          </a:xfrm>
+          <a:prstGeom prst="rect">
+            <a:avLst/>
+          </a:prstGeom>
+        </p:spPr>
+      </p:pic>
+      <p:pic>
+        <p:nvPicPr>
+          <p:cNvPr id="15" name="Arrow 3" descr="next">    </p:cNvPr>
+          <p:cNvPicPr>
+            <a:picLocks noChangeAspect="1"/>
+          </p:cNvPicPr>
+          <p:nvPr/>
+        </p:nvPicPr>
+        <p:blipFill>
+          <a:blip r:embed="rId6"/>
+          <a:stretch>
+            <a:fillRect/>
+          </a:stretch>
+        </p:blipFill>
+        <p:spPr>
+          <a:xfrm>
+            <a:off x="6355080" y="1463040"/>
+            <a:ext cx="320040" cy="320040"/>
+          </a:xfrm>
+          <a:prstGeom prst="rect">
+            <a:avLst/>
+          </a:prstGeom>
+        </p:spPr>
+      </p:pic>
+      <p:sp>
+        <p:nvSpPr>
+          <p:cNvPr id="16" name="Text 8"/>
+          <p:cNvSpPr txBox="1"/>
+          <p:nvPr/>
+        </p:nvSpPr>
+        <p:spPr>
+          <a:xfrm>
+            <a:off x="4663440" y="2148840"/>
+            <a:ext cx="1874520" cy="365760"/>
+          </a:xfrm>
+          <a:prstGeom prst="rect">
+            <a:avLst/>
+          </a:prstGeom>
+          <a:noFill/>
+          <a:ln/>
+        </p:spPr>
+        <p:txBody>
+          <a:bodyPr wrap="square" lIns="0" tIns="0" rIns="0" bIns="0" rtlCol="0" anchor="t"/>
+          <a:lstStyle/>
+          <a:p>
+            <a:pPr algn="ctr" indent="0" marL="0">
+              <a:lnSpc>
+                <a:spcPts val="2000"/>
+              </a:lnSpc>
+              <a:buNone/>
+            </a:pPr>
+            <a:r>
+              <a:rPr lang="en-US" sz="1600" b="1" dirty="0">
+                <a:solidFill>
+                  <a:schemeClr val="tx2"/>
+                </a:solidFill>
+              </a:rPr>
+              <a:t>五日療程</a:t>
+            </a:r>
+            <a:endParaRPr lang="en-US" sz="1600" dirty="0"/>
+          </a:p>
+        </p:txBody>
+      </p:sp>
+      <p:sp>
+        <p:nvSpPr>
+          <p:cNvPr id="17" name="Text 9"/>
+          <p:cNvSpPr txBox="1"/>
+          <p:nvPr/>
+        </p:nvSpPr>
+        <p:spPr>
+          <a:xfrm>
+            <a:off x="4754880" y="2560320"/>
+            <a:ext cx="1691640" cy="777240"/>
+          </a:xfrm>
+          <a:prstGeom prst="rect">
+            <a:avLst/>
+          </a:prstGeom>
+          <a:noFill/>
+          <a:ln/>
+        </p:spPr>
+        <p:txBody>
+          <a:bodyPr wrap="square" lIns="0" tIns="0" rIns="0" bIns="0" rtlCol="0" anchor="t"/>
+          <a:lstStyle/>
+          <a:p>
+            <a:pPr indent="0" marL="0">
+              <a:lnSpc>
+                <a:spcPts val="1500"/>
+              </a:lnSpc>
+              <a:buNone/>
+            </a:pPr>
+            <a:r>
+              <a:rPr lang="en-US" sz="1200" dirty="0">
+                <a:solidFill>
+                  <a:schemeClr val="tx1"/>
+                </a:solidFill>
+              </a:rPr>
+              <a:t>評估 → 放鬆 → 調理 → 整合 → 返家</a:t>
+            </a:r>
+            <a:endParaRPr lang="en-US" sz="1200" dirty="0"/>
+          </a:p>
+        </p:txBody>
+      </p:sp>
+      <p:sp>
+        <p:nvSpPr>
+          <p:cNvPr id="18" name="退房後測 circle"/>
+          <p:cNvSpPr/>
+          <p:nvPr/>
+        </p:nvSpPr>
+        <p:spPr>
+          <a:xfrm>
+            <a:off x="7315200" y="1234440"/>
+            <a:ext cx="777240" cy="777240"/>
+          </a:xfrm>
+          <a:prstGeom prst="ellipse">
+            <a:avLst/>
+          </a:prstGeom>
+          <a:solidFill>
+            <a:srgbClr val="C07A4F"/>
+          </a:solidFill>
+          <a:ln w="12700">
+            <a:solidFill>
+              <a:srgbClr val="C07A4F"/>
+            </a:solidFill>
+            <a:prstDash val="solid"/>
+          </a:ln>
+        </p:spPr>
+      </p:sp>
+      <p:pic>
+        <p:nvPicPr>
+          <p:cNvPr id="19" name="退房後測 icon" descr="退房後測">    </p:cNvPr>
+          <p:cNvPicPr>
+            <a:picLocks noChangeAspect="1"/>
+          </p:cNvPicPr>
+          <p:nvPr/>
+        </p:nvPicPr>
+        <p:blipFill>
+          <a:blip r:embed="rId7"/>
+          <a:stretch>
+            <a:fillRect/>
+          </a:stretch>
+        </p:blipFill>
+        <p:spPr>
+          <a:xfrm>
+            <a:off x="7509510" y="1428750"/>
+            <a:ext cx="388620" cy="388620"/>
+          </a:xfrm>
+          <a:prstGeom prst="rect">
+            <a:avLst/>
+          </a:prstGeom>
+        </p:spPr>
+      </p:pic>
+      <p:sp>
+        <p:nvSpPr>
+          <p:cNvPr id="20" name="Text 11"/>
+          <p:cNvSpPr txBox="1"/>
+          <p:nvPr/>
+        </p:nvSpPr>
+        <p:spPr>
+          <a:xfrm>
+            <a:off x="6766560" y="2148840"/>
+            <a:ext cx="1874520" cy="365760"/>
+          </a:xfrm>
+          <a:prstGeom prst="rect">
+            <a:avLst/>
+          </a:prstGeom>
+          <a:noFill/>
+          <a:ln/>
+        </p:spPr>
+        <p:txBody>
+          <a:bodyPr wrap="square" lIns="0" tIns="0" rIns="0" bIns="0" rtlCol="0" anchor="t"/>
+          <a:lstStyle/>
+          <a:p>
+            <a:pPr algn="ctr" indent="0" marL="0">
+              <a:lnSpc>
+                <a:spcPts val="2000"/>
+              </a:lnSpc>
+              <a:buNone/>
+            </a:pPr>
+            <a:r>
+              <a:rPr lang="en-US" sz="1600" b="1" dirty="0">
+                <a:solidFill>
+                  <a:schemeClr val="tx2"/>
+                </a:solidFill>
+              </a:rPr>
+              <a:t>退房後測</a:t>
+            </a:r>
+            <a:endParaRPr lang="en-US" sz="1600" dirty="0"/>
+          </a:p>
+        </p:txBody>
+      </p:sp>
+      <p:sp>
+        <p:nvSpPr>
+          <p:cNvPr id="21" name="Text 12"/>
+          <p:cNvSpPr txBox="1"/>
+          <p:nvPr/>
+        </p:nvSpPr>
+        <p:spPr>
+          <a:xfrm>
+            <a:off x="6858000" y="2560320"/>
+            <a:ext cx="1691640" cy="777240"/>
+          </a:xfrm>
+          <a:prstGeom prst="rect">
+            <a:avLst/>
+          </a:prstGeom>
+          <a:noFill/>
+          <a:ln/>
+        </p:spPr>
+        <p:txBody>
+          <a:bodyPr wrap="square" lIns="0" tIns="0" rIns="0" bIns="0" rtlCol="0" anchor="t"/>
+          <a:lstStyle/>
+          <a:p>
+            <a:pPr indent="0" marL="0">
+              <a:lnSpc>
+                <a:spcPts val="1500"/>
+              </a:lnSpc>
+              <a:buNone/>
+            </a:pPr>
+            <a:r>
+              <a:rPr lang="en-US" sz="1200" dirty="0">
+                <a:solidFill>
+                  <a:schemeClr val="tx1"/>
+                </a:solidFill>
+              </a:rPr>
+              <a:t>退房前再測一次，與前測對照</a:t>
+            </a:r>
+            <a:endParaRPr lang="en-US" sz="1200" dirty="0"/>
+          </a:p>
+        </p:txBody>
+      </p:sp>
+      <p:sp>
+        <p:nvSpPr>
+          <p:cNvPr id="22" name="Report callout"/>
+          <p:cNvSpPr/>
+          <p:nvPr/>
+        </p:nvSpPr>
+        <p:spPr>
+          <a:xfrm>
+            <a:off x="457200" y="3520440"/>
+            <a:ext cx="8229600" cy="914400"/>
+          </a:xfrm>
+          <a:prstGeom prst="roundRect">
+            <a:avLst>
+              <a:gd name="adj" fmla="val 8000"/>
+            </a:avLst>
+          </a:prstGeom>
+          <a:solidFill>
+            <a:srgbClr val="2F4A3A"/>
+          </a:solidFill>
+          <a:ln w="12700">
+            <a:solidFill>
+              <a:srgbClr val="2F4A3A"/>
+            </a:solidFill>
+            <a:prstDash val="solid"/>
+          </a:ln>
+        </p:spPr>
+      </p:sp>
+      <p:sp>
+        <p:nvSpPr>
+          <p:cNvPr id="23" name="Text 14"/>
+          <p:cNvSpPr txBox="1"/>
+          <p:nvPr/>
+        </p:nvSpPr>
+        <p:spPr>
+          <a:xfrm>
+            <a:off x="731520" y="3520440"/>
+            <a:ext cx="2377440" cy="914400"/>
+          </a:xfrm>
+          <a:prstGeom prst="rect">
+            <a:avLst/>
+          </a:prstGeom>
+          <a:noFill/>
+          <a:ln/>
+        </p:spPr>
+        <p:txBody>
+          <a:bodyPr wrap="square" lIns="0" tIns="0" rIns="0" bIns="0" rtlCol="0" anchor="ctr"/>
+          <a:lstStyle/>
+          <a:p>
+            <a:pPr indent="0" marL="0">
+              <a:lnSpc>
+                <a:spcPts val="2500"/>
+              </a:lnSpc>
+              <a:buNone/>
+            </a:pPr>
+            <a:r>
+              <a:rPr lang="en-US" sz="2000" b="1" dirty="0">
+                <a:solidFill>
+                  <a:schemeClr val="bg1"/>
+                </a:solidFill>
+              </a:rPr>
+              <a:t>「五日健康報告」</a:t>
+            </a:r>
+            <a:endParaRPr lang="en-US" sz="2000" dirty="0"/>
+          </a:p>
+        </p:txBody>
+      </p:sp>
+      <p:sp>
+        <p:nvSpPr>
+          <p:cNvPr id="24" name="Text 15"/>
+          <p:cNvSpPr txBox="1"/>
+          <p:nvPr/>
+        </p:nvSpPr>
+        <p:spPr>
+          <a:xfrm>
+            <a:off x="3200400" y="3520440"/>
+            <a:ext cx="5303520" cy="914400"/>
+          </a:xfrm>
+          <a:prstGeom prst="rect">
+            <a:avLst/>
+          </a:prstGeom>
+          <a:noFill/>
+          <a:ln/>
+        </p:spPr>
+        <p:txBody>
+          <a:bodyPr wrap="square" lIns="0" tIns="0" rIns="0" bIns="0" rtlCol="0" anchor="ctr"/>
+          <a:lstStyle/>
+          <a:p>
+            <a:pPr indent="0" marL="0">
+              <a:lnSpc>
+                <a:spcPts val="1800"/>
+              </a:lnSpc>
+              <a:buNone/>
+            </a:pPr>
+            <a:r>
+              <a:rPr lang="en-US" sz="1400" dirty="0">
+                <a:solidFill>
+                  <a:schemeClr val="accent4"/>
+                </a:solidFill>
+              </a:rPr>
+              <a:t>前後測對照，讓學員看見五天的變化——是口碑與回購的關鍵。</a:t>
+            </a:r>
+            <a:endParaRPr lang="en-US" sz="1400" dirty="0"/>
+          </a:p>
+        </p:txBody>
+      </p:sp>
+      <p:sp>
+        <p:nvSpPr>
+          <p:cNvPr id="25" name="Slide Number Placeholder 0"/>
+          <p:cNvSpPr>
+            <a:spLocks noGrp="1"/>
+          </p:cNvSpPr>
+          <p:nvPr>
+            <p:ph type="sldNum" sz="quarter" idx="4294967295"/>
+          </p:nvPr>
+        </p:nvSpPr>
+        <p:spPr>
+          <a:xfrm>
+            <a:off x="8229600" y="4754880"/>
+            <a:ext cx="457200" cy="274320"/>
+          </a:xfrm>
+          <a:prstGeom prst="rect">
+            <a:avLst/>
+          </a:prstGeom>
+          <a:extLst>
+            <a:ext uri="{C572A759-6A51-4108-AA02-DFA0A04FC94B}">
+              <ma14:wrappingTextBoxFlag xmlns:ma14="http://schemas.microsoft.com/office/mac/drawingml/2011/main" val="0"/>
+            </a:ext>
+          </a:extLst>
+        </p:spPr>
+        <p:txBody>
+          <a:bodyPr/>
+          <a:lstStyle>
+            <a:lvl1pPr>
+              <a:defRPr sz="1000">
+                <a:solidFill>
+                  <a:schemeClr val="accent5"/>
+                </a:solidFill>
+              </a:defRPr>
+            </a:lvl1pPr>
+          </a:lstStyle>
+          <a:p>
+            <a:pPr algn="r"/>
+            <a:fld id="{F7021451-1387-4CA6-816F-3879F97B5CBC}" type="slidenum">
+              <a:rPr b="0" lang="en-US"/>
+              <a:t>11</a:t>
+            </a:fld>
+            <a:endParaRPr lang="en-US"/>
+          </a:p>
+        </p:txBody>
+      </p:sp>
+    </p:spTree>
+  </p:cSld>
+  <p:clrMapOvr>
+    <a:masterClrMapping/>
+  </p:clrMapOvr>
+</p:sld>
+</file>
+
+<file path=ppt/slides/slide12.xml><?xml version="1.0" encoding="utf-8"?>
+<p:sld xmlns:a="http://schemas.openxmlformats.org/drawingml/2006/main" xmlns:r="http://schemas.openxmlformats.org/officeDocument/2006/relationships" xmlns:p="http://schemas.openxmlformats.org/presentationml/2006/main">
+  <p:cSld name="Slide 12">
+    <p:spTree>
+      <p:nvGrpSpPr>
+        <p:cNvPr id="1" name=""/>
+        <p:cNvGrpSpPr/>
+        <p:nvPr/>
+      </p:nvGrpSpPr>
+      <p:grpSpPr>
+        <a:xfrm>
+          <a:off x="0" y="0"/>
+          <a:ext cx="0" cy="0"/>
+          <a:chOff x="0" y="0"/>
+          <a:chExt cx="0" cy="0"/>
+        </a:xfrm>
+      </p:grpSpPr>
+      <p:sp>
+        <p:nvSpPr>
+          <p:cNvPr id="2" name="Text 0"/>
+          <p:cNvSpPr/>
+          <p:nvPr>
+            <p:ph idx="100" type="title" hasCustomPrompt="1"/>
+          </p:nvPr>
+        </p:nvSpPr>
+        <p:spPr>
+          <a:xfrm>
+            <a:off x="457200" y="274320"/>
+            <a:ext cx="8229600" cy="685800"/>
+          </a:xfrm>
+          <a:prstGeom prst="rect">
+            <a:avLst/>
+          </a:prstGeom>
+          <a:noFill/>
+          <a:ln/>
+        </p:spPr>
+        <p:txBody>
+          <a:bodyPr wrap="square" lIns="0" tIns="0" rIns="0" bIns="0" rtlCol="0" anchor="ctr"/>
+          <a:lstStyle/>
+          <a:p>
+            <a:pPr indent="0" marL="0">
+              <a:lnSpc>
+                <a:spcPts val="3400"/>
+              </a:lnSpc>
+              <a:buNone/>
+            </a:pPr>
+            <a:r>
+              <a:rPr lang="en-US" sz="2800" b="1" dirty="0">
+                <a:solidFill>
+                  <a:schemeClr val="tx2"/>
+                </a:solidFill>
+              </a:rPr>
               <a:t>5 天 4 夜行程</a:t>
             </a:r>
             <a:endParaRPr lang="en-US" sz="2800" dirty="0"/>
@@ -3231,7 +4607,7 @@
       </p:sp>
       <p:graphicFrame>
         <p:nvGraphicFramePr>
-          <p:cNvPr id="12" name="Table 0"/>
+          <p:cNvPr id="13" name="Table 0"/>
           <p:cNvGraphicFramePr>
             <a:graphicFrameLocks noGrp="1"/>
           </p:cNvGraphicFramePr>
@@ -4986,7 +6362,7 @@
             <a:pPr algn="r"/>
             <a:fld id="{F7021451-1387-4CA6-816F-3879F97B5CBC}" type="slidenum">
               <a:rPr b="0" lang="en-US"/>
-              <a:t>11</a:t>
+              <a:t>12</a:t>
             </a:fld>
             <a:endParaRPr lang="en-US"/>
           </a:p>
@@ -5000,9 +6376,9 @@
 </p:sld>
 </file>
 
-<file path=ppt/slides/slide12.xml><?xml version="1.0" encoding="utf-8"?>
+<file path=ppt/slides/slide13.xml><?xml version="1.0" encoding="utf-8"?>
 <p:sld xmlns:a="http://schemas.openxmlformats.org/drawingml/2006/main" xmlns:r="http://schemas.openxmlformats.org/officeDocument/2006/relationships" xmlns:p="http://schemas.openxmlformats.org/presentationml/2006/main">
-  <p:cSld name="Slide 12">
+  <p:cSld name="Slide 13">
     <p:spTree>
       <p:nvGrpSpPr>
         <p:cNvPr id="1" name=""/>
@@ -7691,7 +9067,7 @@
                   <a:schemeClr val="tx2"/>
                 </a:solidFill>
               </a:rPr>
-              <a:t>空間規劃：以 8 間客房作為設計樣板</a:t>
+              <a:t>空間規劃：15–20 間客房形成經濟規模</a:t>
             </a:r>
             <a:endParaRPr lang="en-US" sz="2800" dirty="0"/>
           </a:p>
@@ -7732,8 +9108,8 @@
         </p:nvSpPr>
         <p:spPr>
           <a:xfrm>
-            <a:off x="457200" y="1417320"/>
-            <a:ext cx="2377440" cy="1188720"/>
+            <a:off x="457200" y="1508760"/>
+            <a:ext cx="2377440" cy="1005840"/>
           </a:xfrm>
           <a:prstGeom prst="rect">
             <a:avLst/>
@@ -7747,19 +9123,19 @@
           <a:p>
             <a:pPr algn="ctr" indent="0" marL="0">
               <a:lnSpc>
-                <a:spcPts val="9000"/>
-              </a:lnSpc>
-              <a:buNone/>
-            </a:pPr>
-            <a:r>
-              <a:rPr lang="en-US" sz="7200" b="1" dirty="0">
+                <a:spcPts val="6300"/>
+              </a:lnSpc>
+              <a:buNone/>
+            </a:pPr>
+            <a:r>
+              <a:rPr lang="en-US" sz="5000" b="1" dirty="0">
                 <a:solidFill>
                   <a:schemeClr val="bg1"/>
                 </a:solidFill>
               </a:rPr>
-              <a:t>8</a:t>
-            </a:r>
-            <a:endParaRPr lang="en-US" sz="7200" dirty="0"/>
+              <a:t>15–20</a:t>
+            </a:r>
+            <a:endParaRPr lang="en-US" sz="5000" dirty="0"/>
           </a:p>
         </p:txBody>
       </p:sp>
@@ -7835,7 +9211,7 @@
                   <a:schemeClr val="accent4"/>
                 </a:solidFill>
               </a:rPr>
-              <a:t>兼顧個人、伴侶、小家庭與團體活動，又不必承擔大型酒店管理成本</a:t>
+              <a:t>足以分攤療癒師、廚房與活動人力，形成經濟規模；又能維持小團體的陪伴品質</a:t>
             </a:r>
             <a:endParaRPr lang="en-US" sz="1200" dirty="0"/>
           </a:p>
@@ -13450,45 +14826,6 @@
               <a:t>體組成量測、飲食計畫、結業後 30 天追蹤</a:t>
             </a:r>
             <a:endParaRPr lang="en-US" sz="1100" dirty="0"/>
-          </a:p>
-        </p:txBody>
-      </p:sp>
-      <p:sp>
-        <p:nvSpPr>
-          <p:cNvPr id="64" name="Text 62"/>
-          <p:cNvSpPr txBox="1"/>
-          <p:nvPr/>
-        </p:nvSpPr>
-        <p:spPr>
-          <a:xfrm>
-            <a:off x="457200" y="4416552"/>
-            <a:ext cx="8229600" cy="274320"/>
-          </a:xfrm>
-          <a:prstGeom prst="rect">
-            <a:avLst/>
-          </a:prstGeom>
-          <a:noFill/>
-          <a:ln/>
-        </p:spPr>
-        <p:txBody>
-          <a:bodyPr wrap="square" lIns="0" tIns="0" rIns="0" bIns="0" rtlCol="0" anchor="t"/>
-          <a:lstStyle/>
-          <a:p>
-            <a:pPr indent="0" marL="0">
-              <a:lnSpc>
-                <a:spcPts val="1300"/>
-              </a:lnSpc>
-              <a:buNone/>
-            </a:pPr>
-            <a:r>
-              <a:rPr lang="en-US" sz="1000" i="1" dirty="0">
-                <a:solidFill>
-                  <a:schemeClr val="accent3"/>
-                </a:solidFill>
-              </a:rPr>
-              <a:t>康復評估、血壓血糖量測等由合格專業人員執行；涉及醫療的項目與合格醫療機構合作。</a:t>
-            </a:r>
-            <a:endParaRPr lang="en-US" sz="1000" dirty="0"/>
           </a:p>
         </p:txBody>
       </p:sp>

</xml_diff>